<commit_message>
Update name and repo link in presentation
</commit_message>
<xml_diff>
--- a/presentation/DataOps_Pipeline_Presentation.pptx
+++ b/presentation/DataOps_Pipeline_Presentation.pptx
@@ -4,6 +4,9 @@
   <p:sldMasterIdLst>
     <p:sldMasterId id="2147483648" r:id="rId1"/>
   </p:sldMasterIdLst>
+  <p:notesMasterIdLst>
+    <p:notesMasterId r:id="rId16"/>
+  </p:notesMasterIdLst>
   <p:sldIdLst>
     <p:sldId id="256" r:id="rId2"/>
     <p:sldId id="257" r:id="rId3"/>
@@ -20,9 +23,6 @@
     <p:sldId id="268" r:id="rId14"/>
     <p:sldId id="269" r:id="rId15"/>
   </p:sldIdLst>
-  <p:notesMasterIdLst>
-    <p:notesMasterId r:id="rId16"/>
-  </p:notesMasterIdLst>
   <p:sldSz cx="12192000" cy="6858000"/>
   <p:notesSz cx="6858000" cy="12192000"/>
   <p:defaultTextStyle>
@@ -120,13 +120,13 @@
   <p:extLst>
     <p:ext uri="{521415D9-36F7-43E2-AB2F-B90AF26B5E84}">
       <p14:sectionLst xmlns:p14="http://schemas.microsoft.com/office/powerpoint/2010/main">
-        <p14:section name="What was built and why" id="{0d344272-1b9c-22c8-bc8d-3f6169ddc43b}">
+        <p14:section name="What was built and why" id="{0D344272-1B9C-22C8-BC8D-3F6169DDC43B}">
           <p14:sldIdLst>
             <p14:sldId id="256"/>
             <p14:sldId id="257"/>
           </p14:sldIdLst>
         </p14:section>
-        <p14:section name="Architecture, tools and transformations" id="{56c5e75e-3b59-c2f6-9298-1b6f86248d34}">
+        <p14:section name="Architecture, tools and transformations" id="{56C5E75E-3B59-C2F6-9298-1B6F86248D34}">
           <p14:sldIdLst>
             <p14:sldId id="258"/>
             <p14:sldId id="259"/>
@@ -134,7 +134,7 @@
             <p14:sldId id="261"/>
           </p14:sldIdLst>
         </p14:section>
-        <p14:section name="Automation, quality and monitoring" id="{3bceb8dc-f769-e8b8-ecf6-a42c258a3bf1}">
+        <p14:section name="Automation, quality and monitoring" id="{3BCEB8DC-F769-E8B8-ECF6-A42C258A3BF1}">
           <p14:sldIdLst>
             <p14:sldId id="262"/>
             <p14:sldId id="263"/>
@@ -143,7 +143,7 @@
             <p14:sldId id="266"/>
           </p14:sldIdLst>
         </p14:section>
-        <p14:section name="Lessons, scalability and demo" id="{37906476-5b03-7877-7636-b8a60e4a64c6}">
+        <p14:section name="Lessons, scalability and demo" id="{37906476-5B03-7877-7636-B8A60E4A64C6}">
           <p14:sldIdLst>
             <p14:sldId id="267"/>
             <p14:sldId id="268"/>
@@ -181,234 +181,10 @@
           <a:chExt cx="0" cy="0"/>
         </a:xfrm>
       </p:grpSpPr>
-      <p:sp>
-        <p:nvSpPr>
-          <p:cNvPr id="2" name="Header Placeholder 1"/>
-          <p:cNvSpPr>
-            <a:spLocks noGrp="1"/>
-          </p:cNvSpPr>
-          <p:nvPr>
-            <p:ph type="hdr" sz="quarter"/>
-          </p:nvPr>
-        </p:nvSpPr>
-        <p:spPr>
-          <a:xfrm>
-            <a:off x="0" y="0"/>
-            <a:ext cx="2971800" cy="458788"/>
-          </a:xfrm>
-          <a:prstGeom prst="rect">
-            <a:avLst/>
-          </a:prstGeom>
-        </p:spPr>
-        <p:txBody>
-          <a:bodyPr vert="horz" lIns="91440" tIns="45720" rIns="91440" bIns="45720" rtlCol="0"/>
-          <a:lstStyle>
-            <a:lvl1pPr algn="l">
-              <a:defRPr sz="1200"/>
-            </a:lvl1pPr>
-          </a:lstStyle>
-          <a:p>
-            <a:endParaRPr lang="en-US"/>
-          </a:p>
-        </p:txBody>
-      </p:sp>
-      <p:sp>
-        <p:nvSpPr>
-          <p:cNvPr id="3" name="Date Placeholder 2"/>
-          <p:cNvSpPr>
-            <a:spLocks noGrp="1"/>
-          </p:cNvSpPr>
-          <p:nvPr>
-            <p:ph type="dt" idx="1"/>
-          </p:nvPr>
-        </p:nvSpPr>
-        <p:spPr>
-          <a:xfrm>
-            <a:off x="3884613" y="0"/>
-            <a:ext cx="2971800" cy="458788"/>
-          </a:xfrm>
-          <a:prstGeom prst="rect">
-            <a:avLst/>
-          </a:prstGeom>
-        </p:spPr>
-        <p:txBody>
-          <a:bodyPr vert="horz" lIns="91440" tIns="45720" rIns="91440" bIns="45720" rtlCol="0"/>
-          <a:lstStyle>
-            <a:lvl1pPr algn="r">
-              <a:defRPr sz="1200"/>
-            </a:lvl1pPr>
-          </a:lstStyle>
-          <a:p>
-            <a:fld id="{5282F153-3F37-0F45-9E97-73ACFA13230C}" type="datetimeFigureOut">
-              <a:rPr lang="en-US"/>
-              <a:t>7/23/19</a:t>
-            </a:fld>
-            <a:endParaRPr lang="en-US"/>
-          </a:p>
-        </p:txBody>
-      </p:sp>
-      <p:sp>
-        <p:nvSpPr>
-          <p:cNvPr id="4" name="Slide Image Placeholder 3"/>
-          <p:cNvSpPr>
-            <a:spLocks noGrp="1" noRot="1" noChangeAspect="1"/>
-          </p:cNvSpPr>
-          <p:nvPr>
-            <p:ph type="sldImg" idx="2"/>
-          </p:nvPr>
-        </p:nvSpPr>
-        <p:spPr>
-          <a:xfrm>
-            <a:off x="685800" y="1143000"/>
-            <a:ext cx="5486400" cy="3086100"/>
-          </a:xfrm>
-          <a:prstGeom prst="rect">
-            <a:avLst/>
-          </a:prstGeom>
-          <a:noFill/>
-          <a:ln w="12700">
-            <a:solidFill>
-              <a:prstClr val="black"/>
-            </a:solidFill>
-          </a:ln>
-        </p:spPr>
-        <p:txBody>
-          <a:bodyPr vert="horz" lIns="91440" tIns="45720" rIns="91440" bIns="45720" rtlCol="0" anchor="ctr"/>
-          <a:lstStyle/>
-          <a:p>
-            <a:endParaRPr lang="en-US"/>
-          </a:p>
-        </p:txBody>
-      </p:sp>
-      <p:sp>
-        <p:nvSpPr>
-          <p:cNvPr id="5" name="Notes Placeholder 4"/>
-          <p:cNvSpPr>
-            <a:spLocks noGrp="1"/>
-          </p:cNvSpPr>
-          <p:nvPr>
-            <p:ph type="body" sz="quarter" idx="3"/>
-          </p:nvPr>
-        </p:nvSpPr>
-        <p:spPr>
-          <a:xfrm>
-            <a:off x="685800" y="4400550"/>
-            <a:ext cx="5486400" cy="3600450"/>
-          </a:xfrm>
-          <a:prstGeom prst="rect">
-            <a:avLst/>
-          </a:prstGeom>
-        </p:spPr>
-        <p:txBody>
-          <a:bodyPr vert="horz" lIns="91440" tIns="45720" rIns="91440" bIns="45720" rtlCol="0"/>
-          <a:lstStyle/>
-          <a:p>
-            <a:pPr lvl="0"/>
-            <a:r>
-              <a:rPr lang="en-US"/>
-              <a:t>Click to edit Master text styles</a:t>
-            </a:r>
-          </a:p>
-          <a:p>
-            <a:pPr lvl="1"/>
-            <a:r>
-              <a:rPr lang="en-US"/>
-              <a:t>Second level</a:t>
-            </a:r>
-          </a:p>
-          <a:p>
-            <a:pPr lvl="2"/>
-            <a:r>
-              <a:rPr lang="en-US"/>
-              <a:t>Third level</a:t>
-            </a:r>
-          </a:p>
-          <a:p>
-            <a:pPr lvl="3"/>
-            <a:r>
-              <a:rPr lang="en-US"/>
-              <a:t>Fourth level</a:t>
-            </a:r>
-          </a:p>
-          <a:p>
-            <a:pPr lvl="4"/>
-            <a:r>
-              <a:rPr lang="en-US"/>
-              <a:t>Fifth level</a:t>
-            </a:r>
-          </a:p>
-        </p:txBody>
-      </p:sp>
-      <p:sp>
-        <p:nvSpPr>
-          <p:cNvPr id="6" name="Footer Placeholder 5"/>
-          <p:cNvSpPr>
-            <a:spLocks noGrp="1"/>
-          </p:cNvSpPr>
-          <p:nvPr>
-            <p:ph type="ftr" sz="quarter" idx="4"/>
-          </p:nvPr>
-        </p:nvSpPr>
-        <p:spPr>
-          <a:xfrm>
-            <a:off x="0" y="8685213"/>
-            <a:ext cx="2971800" cy="458787"/>
-          </a:xfrm>
-          <a:prstGeom prst="rect">
-            <a:avLst/>
-          </a:prstGeom>
-        </p:spPr>
-        <p:txBody>
-          <a:bodyPr vert="horz" lIns="91440" tIns="45720" rIns="91440" bIns="45720" rtlCol="0" anchor="b"/>
-          <a:lstStyle>
-            <a:lvl1pPr algn="l">
-              <a:defRPr sz="1200"/>
-            </a:lvl1pPr>
-          </a:lstStyle>
-          <a:p>
-            <a:endParaRPr lang="en-US"/>
-          </a:p>
-        </p:txBody>
-      </p:sp>
-      <p:sp>
-        <p:nvSpPr>
-          <p:cNvPr id="7" name="Slide Number Placeholder 6"/>
-          <p:cNvSpPr>
-            <a:spLocks noGrp="1"/>
-          </p:cNvSpPr>
-          <p:nvPr>
-            <p:ph type="sldNum" sz="quarter" idx="5"/>
-          </p:nvPr>
-        </p:nvSpPr>
-        <p:spPr>
-          <a:xfrm>
-            <a:off x="3884613" y="8685213"/>
-            <a:ext cx="2971800" cy="458787"/>
-          </a:xfrm>
-          <a:prstGeom prst="rect">
-            <a:avLst/>
-          </a:prstGeom>
-        </p:spPr>
-        <p:txBody>
-          <a:bodyPr vert="horz" lIns="91440" tIns="45720" rIns="91440" bIns="45720" rtlCol="0" anchor="b"/>
-          <a:lstStyle>
-            <a:lvl1pPr algn="r">
-              <a:defRPr sz="1200"/>
-            </a:lvl1pPr>
-          </a:lstStyle>
-          <a:p>
-            <a:fld id="{CE5E9CC1-C706-0F49-92D6-E571CC5EEA8F}" type="slidenum">
-              <a:rPr lang="en-US"/>
-              <a:t>‹#›</a:t>
-            </a:fld>
-            <a:endParaRPr lang="en-US"/>
-          </a:p>
-        </p:txBody>
-      </p:sp>
     </p:spTree>
     <p:extLst>
       <p:ext uri="{BB962C8B-B14F-4D97-AF65-F5344CB8AC3E}">
-        <p14:creationId xmlns:p14="http://schemas.microsoft.com/office/powerpoint/2010/main" val="1024086991"/>
+        <p14:creationId xmlns:p14="http://schemas.microsoft.com/office/powerpoint/2010/main" val="677467376"/>
       </p:ext>
     </p:extLst>
   </p:cSld>
@@ -556,7 +332,6 @@
               <a:rPr lang="en-US" dirty="0"/>
               <a:t>Hi, I’m [name]. Over the next 12 minutes I’ll walk through a small but complete DataOps pipeline I built for financial transaction data: how it’s designed, how it’s automated, how I keep data quality high, and how it would scale. I’ll finish with a live demo.</a:t>
             </a:r>
-            <a:endParaRPr lang="en-US" dirty="0"/>
           </a:p>
         </p:txBody>
       </p:sp>
@@ -644,7 +419,6 @@
               <a:rPr lang="en-US" dirty="0"/>
               <a:t>Monitoring is file-based so it works anywhere. The log file has one structured JSON line per step, so you can filter by run id or step with any tool. The run report shows the latest run in full, and the run history keeps a line per run, which is how you’d spot a rising reject rate or slower runs over time. These same numbers are what I’d push to Prometheus or CloudWatch in production. Re-runs are safe because outputs are replaced, not appended.</a:t>
             </a:r>
-            <a:endParaRPr lang="en-US" dirty="0"/>
           </a:p>
         </p:txBody>
       </p:sp>
@@ -732,7 +506,6 @@
               <a:rPr lang="en-US" dirty="0"/>
               <a:t>Infrastructure is code in two forms. Docker Compose brings up the whole stack with one command. Terraform does the same with the Docker provider, so terraform apply genuinely creates a network, a Postgres container and the pipeline container in the live demo, with no AWS account and no risk of charges. The one real secret is the Postgres password. It only ever comes from an environment variable: a git-ignored .env locally, GitHub Secrets in CI, and a sensitive Terraform variable. If this moved to AWS, Secrets Manager or Vault would set that same variable and the code wouldn’t change.</a:t>
             </a:r>
-            <a:endParaRPr lang="en-US" dirty="0"/>
           </a:p>
         </p:txBody>
       </p:sp>
@@ -820,7 +593,6 @@
               <a:rPr lang="en-US" dirty="0"/>
               <a:t>A few honest challenges. The dataset was perfectly clean, so I built a seeded dirty batch, and CI now expects it to fail. I wanted real infrastructure as code without a cloud bill, so Terraform uses the Docker provider and Postgres plays Redshift. I wanted one code path everywhere, so all configuration comes from environment variables, with SQLite as a fallback for a quick run without Docker. Re-runs had to be safe, so tables are replaced. And running the container as a non-root user meant preparing the mounted folders’ permissions.</a:t>
             </a:r>
-            <a:endParaRPr lang="en-US" dirty="0"/>
           </a:p>
         </p:txBody>
       </p:sp>
@@ -908,7 +680,6 @@
               <a:rPr lang="en-US" dirty="0"/>
               <a:t>On scalability: the transform functions take a DataFrame and return one, so they port to PySpark with little change. Parquet is partitioned by month, so queries scan only the data they need. The container keeps no state, so it scales out horizontally, and Postgres becomes Redshift with the same SQL. On agility, which matters a lot in finance: when the fraud team needs a new rule, it’s one function and one test, through CI the same day, and a new environment is one terraform apply. Git history, run ids and quarantine files give auditors and regulators the lineage they ask for.</a:t>
             </a:r>
-            <a:endParaRPr lang="en-US" dirty="0"/>
           </a:p>
         </p:txBody>
       </p:sp>
@@ -996,7 +767,6 @@
               <a:rPr lang="en-US" dirty="0"/>
               <a:t>That’s the design. Now the live demo: run the tests, bring up Postgres and the pipeline with Docker Compose, open the run report, feed it the dirty batch and watch the gate stop it, query the Postgres warehouse with SQL, and finally show the green GitHub Actions run with its three jobs. Happy to take questions at any point.</a:t>
             </a:r>
-            <a:endParaRPr lang="en-US" dirty="0"/>
           </a:p>
         </p:txBody>
       </p:sp>
@@ -1084,7 +854,6 @@
               <a:rPr lang="en-US" dirty="0"/>
               <a:t>The brief says “e.g.” for every tool, so I chose the cloud-free option each time. Nothing here needs an AWS account: GitHub Actions runs on GitHub’s own servers, Postgres and the pipeline run in Docker on my laptop, and Terraform uses the Docker provider so terraform apply really works in a live demo. Every requirement maps to a specific file. The dataset is 78,600 metaverse crypto transactions for 2022, with amounts, wallets, regions, risk scores and fraud labels.</a:t>
             </a:r>
-            <a:endParaRPr lang="en-US" dirty="0"/>
           </a:p>
         </p:txBody>
       </p:sp>
@@ -1172,7 +941,6 @@
               <a:rPr lang="en-US" dirty="0"/>
               <a:t>Data flows left to right. Ingest reads every CSV or JSON file from a local landing folder and tags each row with its source file for lineage. Clean fixes types and applies business rules; rows that break a rule go to quarantine with the reason, not silently dropped. Then the quality gate: if too many rows fail, the run stops before anything reaches the warehouse. Enrich adds analytics and ML features, and Store writes Parquet files and loads PostgreSQL running in Docker, my stand-in for Redshift. GitHub Actions, Docker Compose, Terraform, logging and .env secrets wrap around every step, all without a cloud account.</a:t>
             </a:r>
-            <a:endParaRPr lang="en-US" dirty="0"/>
           </a:p>
         </p:txBody>
       </p:sp>
@@ -1260,7 +1028,6 @@
               <a:rPr lang="en-US" dirty="0"/>
               <a:t>Here’s one run on the full dataset. 78,600 rows in, zero rejected because this source file is clean, and three outputs: the enriched fact table with 26 columns, a daily summary by region for dashboards, and a feature table with one row per sending wallet for fraud models. 6,495 transactions are labelled scam or phishing. The whole run takes a few seconds on a laptop.</a:t>
             </a:r>
-            <a:endParaRPr lang="en-US" dirty="0"/>
           </a:p>
         </p:txBody>
       </p:sp>
@@ -1348,7 +1115,6 @@
               <a:rPr lang="en-US" dirty="0"/>
               <a:t>Every tool is free and runs locally, and each has a direct AWS equivalent, so the design carries over unchanged. pandas is right for 78,000 rows; the transforms take and return DataFrames, so they port to PySpark. Postgres stands in for Redshift because they share SQL. Terraform uses the Docker provider, so apply genuinely creates infrastructure in the demo; switching to the AWS provider later changes the resources, not the workflow. Secrets are environment variables, which is exactly how Secrets Manager or Vault would inject them.</a:t>
             </a:r>
-            <a:endParaRPr lang="en-US" dirty="0"/>
           </a:p>
         </p:txBody>
       </p:sp>
@@ -1436,7 +1202,6 @@
               <a:rPr lang="en-US" dirty="0"/>
               <a:t>Transformation is three small functions. Clean makes the data trustworthy: types, text normalisation, a regex check on wallet addresses, and every rejected row keeps its reason. Enrich adds the flags analysts and models actually ask for. Aggregate produces two shapes: a daily summary for dashboards and a per-wallet feature table for fraud models. Each run stamps a run id on every row, so any number can be traced back to the run that produced it.</a:t>
             </a:r>
-            <a:endParaRPr lang="en-US" dirty="0"/>
           </a:p>
         </p:txBody>
       </p:sp>
@@ -1524,7 +1289,6 @@
               <a:rPr lang="en-US" dirty="0"/>
               <a:t>The GitHub Actions workflow runs on GitHub’s own servers, so it needs no cloud account and is free for a public repo. Job one runs the 15 unit tests. Job two checks the Terraform is formatted and valid. Job three runs only if both pass: it builds the Docker image, runs the real pipeline against a throwaway Postgres service, queries the row counts, and then feeds in the dirty batch and expects it to fail. If the gate ever stopped catching bad data, the build would go red. Logs and the run report are uploaded as build artifacts.</a:t>
             </a:r>
-            <a:endParaRPr lang="en-US" dirty="0"/>
           </a:p>
         </p:txBody>
       </p:sp>
@@ -1612,7 +1376,6 @@
               <a:rPr lang="en-US" dirty="0"/>
               <a:t>Quality works at three levels. First, row-level rules: anything that breaks a rule goes to a quarantine file with the reason, so a data steward can fix it at source. Second, a dataset-level gate: if more than 5% of rows are rejected, or any invariant fails, the pipeline exits with code 1 and nothing reaches the warehouse. In finance a missing load is far cheaper than a wrong one. Third, unit tests run in CI on every push, and CI also runs the dirty batch and expects it to fail, so a change that weakens a rule can’t be merged.</a:t>
             </a:r>
-            <a:endParaRPr lang="en-US" dirty="0"/>
           </a:p>
         </p:txBody>
       </p:sp>
@@ -1700,7 +1463,6 @@
               <a:rPr lang="en-US" dirty="0"/>
               <a:t>To prove the gate works, I built a deliberately dirty batch: a negative amount, an invalid wallet, a risk score of 180, an unknown transaction type, a broken timestamp, and two duplicated rows. On the right is the actual log output. Fifteen clean rows, five quarantined, two duplicates dropped, and because 22.7% is above the 5% limit, the run fails and nothing is loaded into Postgres. I’ll run this live in the demo.</a:t>
             </a:r>
-            <a:endParaRPr lang="en-US" dirty="0"/>
           </a:p>
         </p:txBody>
       </p:sp>
@@ -1778,6 +1540,7 @@
         <a:solidFill>
           <a:schemeClr val="bg1"/>
         </a:solidFill>
+        <a:effectLst/>
       </p:bgPr>
     </p:bg>
     <p:spTree>
@@ -1797,9 +1560,11 @@
       <p:sp>
         <p:nvSpPr>
           <p:cNvPr id="2" name="Text 0"/>
-          <p:cNvSpPr/>
+          <p:cNvSpPr>
+            <a:spLocks noGrp="1"/>
+          </p:cNvSpPr>
           <p:nvPr>
-            <p:ph idx="100" type="body" hasCustomPrompt="1"/>
+            <p:ph type="body" idx="100" hasCustomPrompt="1"/>
           </p:nvPr>
         </p:nvSpPr>
         <p:spPr>
@@ -1816,9 +1581,9 @@
         <p:txBody>
           <a:bodyPr wrap="square" rtlCol="0"/>
           <a:lstStyle>
-            <a:lvl1pPr indent="0" marL="0">
-              <a:buNone/>
-              <a:defRPr lang="en-US" sz="1300" spc="200" kern="0" dirty="0">
+            <a:lvl1pPr marL="0" indent="0">
+              <a:buNone/>
+              <a:defRPr lang="en-US" sz="1300" kern="0" spc="200" dirty="0">
                 <a:solidFill>
                   <a:schemeClr val="accent1"/>
                 </a:solidFill>
@@ -1829,7 +1594,7 @@
             </a:lvl1pPr>
           </a:lstStyle>
           <a:p>
-            <a:pPr indent="0" marL="0">
+            <a:pPr marL="0" indent="0">
               <a:buNone/>
             </a:pPr>
             <a:endParaRPr lang="en-US" sz="1300" dirty="0"/>
@@ -1839,9 +1604,11 @@
       <p:sp>
         <p:nvSpPr>
           <p:cNvPr id="3" name="Text 0"/>
-          <p:cNvSpPr/>
+          <p:cNvSpPr>
+            <a:spLocks noGrp="1"/>
+          </p:cNvSpPr>
           <p:nvPr>
-            <p:ph idx="101" type="title" hasCustomPrompt="1"/>
+            <p:ph type="title" idx="101" hasCustomPrompt="1"/>
           </p:nvPr>
         </p:nvSpPr>
         <p:spPr>
@@ -1858,7 +1625,7 @@
         <p:txBody>
           <a:bodyPr wrap="square" rtlCol="0"/>
           <a:lstStyle>
-            <a:lvl1pPr algn="l" indent="0" marL="0">
+            <a:lvl1pPr marL="0" indent="0" algn="l">
               <a:buNone/>
               <a:defRPr lang="en-US" sz="3400" b="1" dirty="0">
                 <a:solidFill>
@@ -1868,7 +1635,7 @@
             </a:lvl1pPr>
           </a:lstStyle>
           <a:p>
-            <a:pPr algn="l" indent="0" marL="0">
+            <a:pPr marL="0" indent="0" algn="l">
               <a:buNone/>
             </a:pPr>
             <a:endParaRPr lang="en-US" sz="3400" dirty="0"/>
@@ -1895,7 +1662,7 @@
           </a:prstGeom>
           <a:extLst>
             <a:ext uri="{C572A759-6A51-4108-AA02-DFA0A04FC94B}">
-              <ma14:wrappingTextBoxFlag xmlns:ma14="http://schemas.microsoft.com/office/mac/drawingml/2011/main" val="0"/>
+              <ma14:wrappingTextBoxFlag xmlns:ma14="http://schemas.microsoft.com/office/mac/drawingml/2011/main" xmlns="" val="0"/>
             </a:ext>
           </a:extLst>
         </p:spPr>
@@ -1913,8 +1680,8 @@
           <a:p>
             <a:pPr algn="r"/>
             <a:fld id="{F7021451-1387-4CA6-816F-3879F97B5CBC}" type="slidenum">
-              <a:rPr b="0" lang="en-US"/>
-              <a:t>1002</a:t>
+              <a:rPr lang="en-US" b="0"/>
+              <a:t>‹#›</a:t>
             </a:fld>
             <a:endParaRPr lang="en-US"/>
           </a:p>
@@ -1936,6 +1703,7 @@
         <a:solidFill>
           <a:schemeClr val="tx1"/>
         </a:solidFill>
+        <a:effectLst/>
       </p:bgPr>
     </p:bg>
     <p:spTree>
@@ -1955,9 +1723,11 @@
       <p:sp>
         <p:nvSpPr>
           <p:cNvPr id="2" name="Text 0"/>
-          <p:cNvSpPr/>
+          <p:cNvSpPr>
+            <a:spLocks noGrp="1"/>
+          </p:cNvSpPr>
           <p:nvPr>
-            <p:ph idx="100" type="body" hasCustomPrompt="1"/>
+            <p:ph type="body" idx="100" hasCustomPrompt="1"/>
           </p:nvPr>
         </p:nvSpPr>
         <p:spPr>
@@ -1974,9 +1744,9 @@
         <p:txBody>
           <a:bodyPr wrap="square" rtlCol="0"/>
           <a:lstStyle>
-            <a:lvl1pPr indent="0" marL="0">
-              <a:buNone/>
-              <a:defRPr lang="en-US" sz="1300" spc="200" kern="0" dirty="0">
+            <a:lvl1pPr marL="0" indent="0">
+              <a:buNone/>
+              <a:defRPr lang="en-US" sz="1300" kern="0" spc="200" dirty="0">
                 <a:solidFill>
                   <a:schemeClr val="accent5"/>
                 </a:solidFill>
@@ -1987,7 +1757,7 @@
             </a:lvl1pPr>
           </a:lstStyle>
           <a:p>
-            <a:pPr indent="0" marL="0">
+            <a:pPr marL="0" indent="0">
               <a:buNone/>
             </a:pPr>
             <a:endParaRPr lang="en-US" sz="1300" dirty="0"/>
@@ -1997,9 +1767,11 @@
       <p:sp>
         <p:nvSpPr>
           <p:cNvPr id="3" name="Text 0"/>
-          <p:cNvSpPr/>
+          <p:cNvSpPr>
+            <a:spLocks noGrp="1"/>
+          </p:cNvSpPr>
           <p:nvPr>
-            <p:ph idx="101" type="title" hasCustomPrompt="1"/>
+            <p:ph type="title" idx="101" hasCustomPrompt="1"/>
           </p:nvPr>
         </p:nvSpPr>
         <p:spPr>
@@ -2016,7 +1788,7 @@
         <p:txBody>
           <a:bodyPr wrap="square" rtlCol="0"/>
           <a:lstStyle>
-            <a:lvl1pPr algn="l" indent="0" marL="0">
+            <a:lvl1pPr marL="0" indent="0" algn="l">
               <a:buNone/>
               <a:defRPr lang="en-US" sz="3600" b="1" dirty="0">
                 <a:solidFill>
@@ -2026,7 +1798,7 @@
             </a:lvl1pPr>
           </a:lstStyle>
           <a:p>
-            <a:pPr algn="l" indent="0" marL="0">
+            <a:pPr marL="0" indent="0" algn="l">
               <a:buNone/>
             </a:pPr>
             <a:endParaRPr lang="en-US" sz="3600" dirty="0"/>
@@ -2053,7 +1825,7 @@
           </a:prstGeom>
           <a:extLst>
             <a:ext uri="{C572A759-6A51-4108-AA02-DFA0A04FC94B}">
-              <ma14:wrappingTextBoxFlag xmlns:ma14="http://schemas.microsoft.com/office/mac/drawingml/2011/main" val="0"/>
+              <ma14:wrappingTextBoxFlag xmlns:ma14="http://schemas.microsoft.com/office/mac/drawingml/2011/main" xmlns="" val="0"/>
             </a:ext>
           </a:extLst>
         </p:spPr>
@@ -2071,8 +1843,8 @@
           <a:p>
             <a:pPr algn="r"/>
             <a:fld id="{F7021451-1387-4CA6-816F-3879F97B5CBC}" type="slidenum">
-              <a:rPr b="0" lang="en-US"/>
-              <a:t>1003</a:t>
+              <a:rPr lang="en-US" b="0"/>
+              <a:t>‹#›</a:t>
             </a:fld>
             <a:endParaRPr lang="en-US"/>
           </a:p>
@@ -2089,6 +1861,11 @@
 <file path=ppt/slideMasters/slideMaster1.xml><?xml version="1.0" encoding="utf-8"?>
 <p:sldMaster xmlns:a="http://schemas.openxmlformats.org/drawingml/2006/main" xmlns:r="http://schemas.openxmlformats.org/officeDocument/2006/relationships" xmlns:p="http://schemas.openxmlformats.org/presentationml/2006/main">
   <p:cSld>
+    <p:bg>
+      <p:bgRef idx="1001">
+        <a:schemeClr val="bg1"/>
+      </p:bgRef>
+    </p:bg>
     <p:spTree>
       <p:nvGrpSpPr>
         <p:cNvPr id="1" name=""/>
@@ -2123,7 +1900,7 @@
           </a:prstGeom>
           <a:extLst>
             <a:ext uri="{C572A759-6A51-4108-AA02-DFA0A04FC94B}">
-              <ma14:wrappingTextBoxFlag xmlns:ma14="http://schemas.microsoft.com/office/mac/drawingml/2011/main" val="0"/>
+              <ma14:wrappingTextBoxFlag xmlns:ma14="http://schemas.microsoft.com/office/mac/drawingml/2011/main" xmlns="" val="0"/>
             </a:ext>
           </a:extLst>
         </p:spPr>
@@ -2141,8 +1918,8 @@
           <a:p>
             <a:pPr algn="r"/>
             <a:fld id="{F7021451-1387-4CA6-816F-3879F97B5CBC}" type="slidenum">
-              <a:rPr b="0" lang="en-US"/>
-              <a:t>null</a:t>
+              <a:rPr lang="en-US" b="0"/>
+              <a:t>‹#›</a:t>
             </a:fld>
             <a:endParaRPr lang="en-US"/>
           </a:p>
@@ -2430,9 +2207,11 @@
       <p:sp>
         <p:nvSpPr>
           <p:cNvPr id="2" name="Text 0"/>
-          <p:cNvSpPr/>
+          <p:cNvSpPr>
+            <a:spLocks noGrp="1"/>
+          </p:cNvSpPr>
           <p:nvPr>
-            <p:ph idx="100" type="body" hasCustomPrompt="1"/>
+            <p:ph type="body" idx="100" hasCustomPrompt="1"/>
           </p:nvPr>
         </p:nvSpPr>
         <p:spPr>
@@ -2450,11 +2229,11 @@
           <a:bodyPr wrap="square" lIns="0" tIns="0" rIns="0" bIns="0" rtlCol="0"/>
           <a:lstStyle/>
           <a:p>
-            <a:pPr indent="0" marL="0">
-              <a:buNone/>
-            </a:pPr>
-            <a:r>
-              <a:rPr lang="en-US" sz="1300" spc="200" kern="0" dirty="0">
+            <a:pPr marL="0" indent="0">
+              <a:buNone/>
+            </a:pPr>
+            <a:r>
+              <a:rPr lang="en-US" sz="1300" kern="0" spc="200" dirty="0">
                 <a:solidFill>
                   <a:schemeClr val="accent5"/>
                 </a:solidFill>
@@ -2489,7 +2268,7 @@
           <a:bodyPr wrap="square" lIns="0" tIns="0" rIns="0" bIns="0" rtlCol="0" anchor="t"/>
           <a:lstStyle/>
           <a:p>
-            <a:pPr indent="0" marL="0">
+            <a:pPr marL="0" indent="0">
               <a:buNone/>
             </a:pPr>
             <a:r>
@@ -2528,7 +2307,7 @@
           <a:bodyPr wrap="square" lIns="0" tIns="0" rIns="0" bIns="0" rtlCol="0" anchor="t"/>
           <a:lstStyle/>
           <a:p>
-            <a:pPr indent="0" marL="0">
+            <a:pPr marL="0" indent="0">
               <a:buNone/>
             </a:pPr>
             <a:r>
@@ -2564,7 +2343,7 @@
           <a:bodyPr wrap="square" lIns="0" tIns="0" rIns="0" bIns="0" rtlCol="0" anchor="t"/>
           <a:lstStyle/>
           <a:p>
-            <a:pPr indent="0" marL="0">
+            <a:pPr marL="0" indent="0">
               <a:buNone/>
             </a:pPr>
             <a:r>
@@ -2573,7 +2352,7 @@
                   <a:schemeClr val="accent6"/>
                 </a:solidFill>
               </a:rPr>
-              <a:t>[Your name]</a:t>
+              <a:t>Shree Ramji</a:t>
             </a:r>
             <a:endParaRPr lang="en-US" sz="1500" dirty="0"/>
           </a:p>
@@ -2600,7 +2379,7 @@
           <a:bodyPr wrap="square" lIns="0" tIns="0" rIns="0" bIns="0" rtlCol="0" anchor="t"/>
           <a:lstStyle/>
           <a:p>
-            <a:pPr indent="0" marL="0">
+            <a:pPr marL="0" indent="0">
               <a:buNone/>
             </a:pPr>
             <a:r>
@@ -2615,36 +2394,6 @@
               <a:t>Python · PostgreSQL · Docker · Terraform · GitHub Actions</a:t>
             </a:r>
             <a:endParaRPr lang="en-US" sz="1500" dirty="0"/>
-          </a:p>
-        </p:txBody>
-      </p:sp>
-      <p:sp>
-        <p:nvSpPr>
-          <p:cNvPr id="8" name="Text 0"/>
-          <p:cNvSpPr/>
-          <p:nvPr>
-            <p:ph idx="101" type="title" hasCustomPrompt="1"/>
-          </p:nvPr>
-        </p:nvSpPr>
-        <p:spPr>
-          <a:xfrm>
-            <a:off x="548640" y="731520"/>
-            <a:ext cx="11094415" cy="1280160"/>
-          </a:xfrm>
-          <a:prstGeom prst="rect">
-            <a:avLst/>
-          </a:prstGeom>
-          <a:noFill/>
-          <a:ln/>
-        </p:spPr>
-        <p:txBody>
-          <a:bodyPr wrap="square" lIns="0" tIns="0" rIns="0" bIns="0" rtlCol="0" anchor="t"/>
-          <a:lstStyle/>
-          <a:p>
-            <a:pPr algn="l" indent="0" marL="0">
-              <a:buNone/>
-            </a:pPr>
-            <a:endParaRPr lang="en-US" sz="3600" dirty="0"/>
           </a:p>
         </p:txBody>
       </p:sp>
@@ -2668,7 +2417,7 @@
           </a:prstGeom>
           <a:extLst>
             <a:ext uri="{C572A759-6A51-4108-AA02-DFA0A04FC94B}">
-              <ma14:wrappingTextBoxFlag xmlns:ma14="http://schemas.microsoft.com/office/mac/drawingml/2011/main" val="0"/>
+              <ma14:wrappingTextBoxFlag xmlns:ma14="http://schemas.microsoft.com/office/mac/drawingml/2011/main" xmlns="" val="0"/>
             </a:ext>
           </a:extLst>
         </p:spPr>
@@ -2686,7 +2435,7 @@
           <a:p>
             <a:pPr algn="r"/>
             <a:fld id="{F7021451-1387-4CA6-816F-3879F97B5CBC}" type="slidenum">
-              <a:rPr b="0" lang="en-US"/>
+              <a:rPr lang="en-US" b="0"/>
               <a:t>1</a:t>
             </a:fld>
             <a:endParaRPr lang="en-US"/>
@@ -2721,9 +2470,11 @@
       <p:sp>
         <p:nvSpPr>
           <p:cNvPr id="2" name="Text 0"/>
-          <p:cNvSpPr/>
+          <p:cNvSpPr>
+            <a:spLocks noGrp="1"/>
+          </p:cNvSpPr>
           <p:nvPr>
-            <p:ph idx="100" type="body" hasCustomPrompt="1"/>
+            <p:ph type="body" idx="100" hasCustomPrompt="1"/>
           </p:nvPr>
         </p:nvSpPr>
         <p:spPr>
@@ -2741,11 +2492,11 @@
           <a:bodyPr wrap="square" lIns="0" tIns="0" rIns="0" bIns="0" rtlCol="0"/>
           <a:lstStyle/>
           <a:p>
-            <a:pPr indent="0" marL="0">
-              <a:buNone/>
-            </a:pPr>
-            <a:r>
-              <a:rPr lang="en-US" sz="1300" spc="200" kern="0" dirty="0">
+            <a:pPr marL="0" indent="0">
+              <a:buNone/>
+            </a:pPr>
+            <a:r>
+              <a:rPr lang="en-US" sz="1300" kern="0" spc="200" dirty="0">
                 <a:solidFill>
                   <a:schemeClr val="accent1"/>
                 </a:solidFill>
@@ -2762,9 +2513,11 @@
       <p:sp>
         <p:nvSpPr>
           <p:cNvPr id="3" name="Text 0"/>
-          <p:cNvSpPr/>
+          <p:cNvSpPr>
+            <a:spLocks noGrp="1"/>
+          </p:cNvSpPr>
           <p:nvPr>
-            <p:ph idx="101" type="title" hasCustomPrompt="1"/>
+            <p:ph type="title" idx="101" hasCustomPrompt="1"/>
           </p:nvPr>
         </p:nvSpPr>
         <p:spPr>
@@ -2782,7 +2535,7 @@
           <a:bodyPr wrap="square" lIns="0" tIns="0" rIns="0" bIns="0" rtlCol="0" anchor="t"/>
           <a:lstStyle/>
           <a:p>
-            <a:pPr algn="l" indent="0" marL="0">
+            <a:pPr marL="0" indent="0" algn="l">
               <a:buNone/>
             </a:pPr>
             <a:r>
@@ -2823,6 +2576,13 @@
             <a:prstDash val="solid"/>
           </a:ln>
         </p:spPr>
+        <p:txBody>
+          <a:bodyPr/>
+          <a:lstStyle/>
+          <a:p>
+            <a:endParaRPr lang="en-IN"/>
+          </a:p>
+        </p:txBody>
       </p:sp>
       <p:sp>
         <p:nvSpPr>
@@ -2843,17 +2603,24 @@
           </a:solidFill>
           <a:ln/>
         </p:spPr>
+        <p:txBody>
+          <a:bodyPr/>
+          <a:lstStyle/>
+          <a:p>
+            <a:endParaRPr lang="en-IN"/>
+          </a:p>
+        </p:txBody>
       </p:sp>
       <p:pic>
         <p:nvPicPr>
-          <p:cNvPr id="6" name="Image 0" descr="pipeline.log icon">    </p:cNvPr>
+          <p:cNvPr id="6" name="Image 0" descr="pipeline.log icon"/>
           <p:cNvPicPr>
             <a:picLocks noChangeAspect="1"/>
           </p:cNvPicPr>
           <p:nvPr/>
         </p:nvPicPr>
         <p:blipFill>
-          <a:blip r:embed="rId1"/>
+          <a:blip r:embed="rId3"/>
           <a:stretch>
             <a:fillRect/>
           </a:stretch>
@@ -2889,7 +2656,7 @@
           <a:bodyPr wrap="square" lIns="0" tIns="0" rIns="0" bIns="0" rtlCol="0" anchor="t"/>
           <a:lstStyle/>
           <a:p>
-            <a:pPr indent="0" marL="0">
+            <a:pPr marL="0" indent="0">
               <a:buNone/>
             </a:pPr>
             <a:r>
@@ -2928,7 +2695,7 @@
           <a:bodyPr wrap="square" lIns="0" tIns="0" rIns="0" bIns="0" rtlCol="0" anchor="t"/>
           <a:lstStyle/>
           <a:p>
-            <a:pPr indent="0" marL="0">
+            <a:pPr marL="0" indent="0">
               <a:buNone/>
             </a:pPr>
             <a:r>
@@ -2969,6 +2736,13 @@
             <a:prstDash val="solid"/>
           </a:ln>
         </p:spPr>
+        <p:txBody>
+          <a:bodyPr/>
+          <a:lstStyle/>
+          <a:p>
+            <a:endParaRPr lang="en-IN"/>
+          </a:p>
+        </p:txBody>
       </p:sp>
       <p:sp>
         <p:nvSpPr>
@@ -2989,17 +2763,24 @@
           </a:solidFill>
           <a:ln/>
         </p:spPr>
+        <p:txBody>
+          <a:bodyPr/>
+          <a:lstStyle/>
+          <a:p>
+            <a:endParaRPr lang="en-IN"/>
+          </a:p>
+        </p:txBody>
       </p:sp>
       <p:pic>
         <p:nvPicPr>
-          <p:cNvPr id="11" name="Image 1" descr="run_report.json icon">    </p:cNvPr>
+          <p:cNvPr id="11" name="Image 1" descr="run_report.json icon"/>
           <p:cNvPicPr>
             <a:picLocks noChangeAspect="1"/>
           </p:cNvPicPr>
           <p:nvPr/>
         </p:nvPicPr>
         <p:blipFill>
-          <a:blip r:embed="rId2"/>
+          <a:blip r:embed="rId4"/>
           <a:stretch>
             <a:fillRect/>
           </a:stretch>
@@ -3035,7 +2816,7 @@
           <a:bodyPr wrap="square" lIns="0" tIns="0" rIns="0" bIns="0" rtlCol="0" anchor="t"/>
           <a:lstStyle/>
           <a:p>
-            <a:pPr indent="0" marL="0">
+            <a:pPr marL="0" indent="0">
               <a:buNone/>
             </a:pPr>
             <a:r>
@@ -3074,7 +2855,7 @@
           <a:bodyPr wrap="square" lIns="0" tIns="0" rIns="0" bIns="0" rtlCol="0" anchor="t"/>
           <a:lstStyle/>
           <a:p>
-            <a:pPr indent="0" marL="0">
+            <a:pPr marL="0" indent="0">
               <a:buNone/>
             </a:pPr>
             <a:r>
@@ -3115,6 +2896,13 @@
             <a:prstDash val="solid"/>
           </a:ln>
         </p:spPr>
+        <p:txBody>
+          <a:bodyPr/>
+          <a:lstStyle/>
+          <a:p>
+            <a:endParaRPr lang="en-IN"/>
+          </a:p>
+        </p:txBody>
       </p:sp>
       <p:sp>
         <p:nvSpPr>
@@ -3135,17 +2923,24 @@
           </a:solidFill>
           <a:ln/>
         </p:spPr>
+        <p:txBody>
+          <a:bodyPr/>
+          <a:lstStyle/>
+          <a:p>
+            <a:endParaRPr lang="en-IN"/>
+          </a:p>
+        </p:txBody>
       </p:sp>
       <p:pic>
         <p:nvPicPr>
-          <p:cNvPr id="16" name="Image 2" descr="run_history.csv icon">    </p:cNvPr>
+          <p:cNvPr id="16" name="Image 2" descr="run_history.csv icon"/>
           <p:cNvPicPr>
             <a:picLocks noChangeAspect="1"/>
           </p:cNvPicPr>
           <p:nvPr/>
         </p:nvPicPr>
         <p:blipFill>
-          <a:blip r:embed="rId3"/>
+          <a:blip r:embed="rId5"/>
           <a:stretch>
             <a:fillRect/>
           </a:stretch>
@@ -3181,7 +2976,7 @@
           <a:bodyPr wrap="square" lIns="0" tIns="0" rIns="0" bIns="0" rtlCol="0" anchor="t"/>
           <a:lstStyle/>
           <a:p>
-            <a:pPr indent="0" marL="0">
+            <a:pPr marL="0" indent="0">
               <a:buNone/>
             </a:pPr>
             <a:r>
@@ -3220,7 +3015,7 @@
           <a:bodyPr wrap="square" lIns="0" tIns="0" rIns="0" bIns="0" rtlCol="0" anchor="t"/>
           <a:lstStyle/>
           <a:p>
-            <a:pPr indent="0" marL="0">
+            <a:pPr marL="0" indent="0">
               <a:buNone/>
             </a:pPr>
             <a:r>
@@ -3256,7 +3051,7 @@
           <a:bodyPr wrap="square" lIns="0" tIns="0" rIns="0" bIns="0" rtlCol="0" anchor="t"/>
           <a:lstStyle/>
           <a:p>
-            <a:pPr indent="0" marL="0">
+            <a:pPr marL="0" indent="0">
               <a:buNone/>
             </a:pPr>
             <a:r>
@@ -3267,9 +3062,6 @@
               </a:rPr>
               <a:t>Operations: </a:t>
             </a:r>
-            <a:pPr indent="0" marL="0">
-              <a:buNone/>
-            </a:pPr>
             <a:r>
               <a:rPr lang="en-US" sz="1600" dirty="0">
                 <a:solidFill>
@@ -3302,7 +3094,7 @@
           </a:prstGeom>
           <a:extLst>
             <a:ext uri="{C572A759-6A51-4108-AA02-DFA0A04FC94B}">
-              <ma14:wrappingTextBoxFlag xmlns:ma14="http://schemas.microsoft.com/office/mac/drawingml/2011/main" val="0"/>
+              <ma14:wrappingTextBoxFlag xmlns:ma14="http://schemas.microsoft.com/office/mac/drawingml/2011/main" xmlns="" val="0"/>
             </a:ext>
           </a:extLst>
         </p:spPr>
@@ -3320,7 +3112,7 @@
           <a:p>
             <a:pPr algn="r"/>
             <a:fld id="{F7021451-1387-4CA6-816F-3879F97B5CBC}" type="slidenum">
-              <a:rPr b="0" lang="en-US"/>
+              <a:rPr lang="en-US" b="0"/>
               <a:t>10</a:t>
             </a:fld>
             <a:endParaRPr lang="en-US"/>
@@ -3355,9 +3147,11 @@
       <p:sp>
         <p:nvSpPr>
           <p:cNvPr id="2" name="Text 0"/>
-          <p:cNvSpPr/>
+          <p:cNvSpPr>
+            <a:spLocks noGrp="1"/>
+          </p:cNvSpPr>
           <p:nvPr>
-            <p:ph idx="100" type="body" hasCustomPrompt="1"/>
+            <p:ph type="body" idx="100" hasCustomPrompt="1"/>
           </p:nvPr>
         </p:nvSpPr>
         <p:spPr>
@@ -3375,11 +3169,11 @@
           <a:bodyPr wrap="square" lIns="0" tIns="0" rIns="0" bIns="0" rtlCol="0"/>
           <a:lstStyle/>
           <a:p>
-            <a:pPr indent="0" marL="0">
-              <a:buNone/>
-            </a:pPr>
-            <a:r>
-              <a:rPr lang="en-US" sz="1300" spc="200" kern="0" dirty="0">
+            <a:pPr marL="0" indent="0">
+              <a:buNone/>
+            </a:pPr>
+            <a:r>
+              <a:rPr lang="en-US" sz="1300" kern="0" spc="200" dirty="0">
                 <a:solidFill>
                   <a:schemeClr val="accent1"/>
                 </a:solidFill>
@@ -3396,9 +3190,11 @@
       <p:sp>
         <p:nvSpPr>
           <p:cNvPr id="3" name="Text 0"/>
-          <p:cNvSpPr/>
+          <p:cNvSpPr>
+            <a:spLocks noGrp="1"/>
+          </p:cNvSpPr>
           <p:nvPr>
-            <p:ph idx="101" type="title" hasCustomPrompt="1"/>
+            <p:ph type="title" idx="101" hasCustomPrompt="1"/>
           </p:nvPr>
         </p:nvSpPr>
         <p:spPr>
@@ -3416,7 +3212,7 @@
           <a:bodyPr wrap="square" lIns="0" tIns="0" rIns="0" bIns="0" rtlCol="0" anchor="t"/>
           <a:lstStyle/>
           <a:p>
-            <a:pPr algn="l" indent="0" marL="0">
+            <a:pPr marL="0" indent="0" algn="l">
               <a:buNone/>
             </a:pPr>
             <a:r>
@@ -3452,6 +3248,13 @@
           </a:solidFill>
           <a:ln/>
         </p:spPr>
+        <p:txBody>
+          <a:bodyPr/>
+          <a:lstStyle/>
+          <a:p>
+            <a:endParaRPr lang="en-IN"/>
+          </a:p>
+        </p:txBody>
       </p:sp>
       <p:sp>
         <p:nvSpPr>
@@ -3474,7 +3277,7 @@
           <a:bodyPr wrap="square" lIns="0" tIns="0" rIns="0" bIns="0" rtlCol="0" anchor="t"/>
           <a:lstStyle/>
           <a:p>
-            <a:pPr indent="0" marL="0">
+            <a:pPr marL="0" indent="0">
               <a:spcAft>
                 <a:spcPts val="600"/>
               </a:spcAft>
@@ -3494,7 +3297,7 @@
             <a:endParaRPr lang="en-US" sz="1500" dirty="0"/>
           </a:p>
           <a:p>
-            <a:pPr indent="0" marL="0">
+            <a:pPr marL="0" indent="0">
               <a:spcAft>
                 <a:spcPts val="600"/>
               </a:spcAft>
@@ -3514,7 +3317,7 @@
             <a:endParaRPr lang="en-US" sz="1500" dirty="0"/>
           </a:p>
           <a:p>
-            <a:pPr indent="0" marL="0">
+            <a:pPr marL="0" indent="0">
               <a:spcAft>
                 <a:spcPts val="600"/>
               </a:spcAft>
@@ -3534,7 +3337,7 @@
             <a:endParaRPr lang="en-US" sz="1500" dirty="0"/>
           </a:p>
           <a:p>
-            <a:pPr indent="0" marL="0">
+            <a:pPr marL="0" indent="0">
               <a:spcAft>
                 <a:spcPts val="600"/>
               </a:spcAft>
@@ -3576,7 +3379,7 @@
           <a:bodyPr wrap="square" lIns="0" tIns="0" rIns="0" bIns="0" rtlCol="0" anchor="t"/>
           <a:lstStyle/>
           <a:p>
-            <a:pPr indent="0" marL="0">
+            <a:pPr marL="0" indent="0">
               <a:buNone/>
             </a:pPr>
             <a:r>
@@ -3617,6 +3420,13 @@
             <a:prstDash val="solid"/>
           </a:ln>
         </p:spPr>
+        <p:txBody>
+          <a:bodyPr/>
+          <a:lstStyle/>
+          <a:p>
+            <a:endParaRPr lang="en-IN"/>
+          </a:p>
+        </p:txBody>
       </p:sp>
       <p:sp>
         <p:nvSpPr>
@@ -3639,7 +3449,7 @@
           <a:bodyPr wrap="square" lIns="0" tIns="0" rIns="0" bIns="0" rtlCol="0" anchor="t"/>
           <a:lstStyle/>
           <a:p>
-            <a:pPr indent="0" marL="0">
+            <a:pPr marL="0" indent="0">
               <a:buNone/>
             </a:pPr>
             <a:r>
@@ -3675,7 +3485,7 @@
           <a:bodyPr wrap="square" lIns="0" tIns="0" rIns="0" bIns="0" rtlCol="0" anchor="t"/>
           <a:lstStyle/>
           <a:p>
-            <a:pPr indent="0" marL="0">
+            <a:pPr marL="0" indent="0">
               <a:buNone/>
             </a:pPr>
             <a:r>
@@ -3716,6 +3526,13 @@
             <a:prstDash val="solid"/>
           </a:ln>
         </p:spPr>
+        <p:txBody>
+          <a:bodyPr/>
+          <a:lstStyle/>
+          <a:p>
+            <a:endParaRPr lang="en-IN"/>
+          </a:p>
+        </p:txBody>
       </p:sp>
       <p:sp>
         <p:nvSpPr>
@@ -3738,7 +3555,7 @@
           <a:bodyPr wrap="square" lIns="0" tIns="0" rIns="0" bIns="0" rtlCol="0" anchor="t"/>
           <a:lstStyle/>
           <a:p>
-            <a:pPr indent="0" marL="0">
+            <a:pPr marL="0" indent="0">
               <a:buNone/>
             </a:pPr>
             <a:r>
@@ -3774,7 +3591,7 @@
           <a:bodyPr wrap="square" lIns="0" tIns="0" rIns="0" bIns="0" rtlCol="0" anchor="t"/>
           <a:lstStyle/>
           <a:p>
-            <a:pPr indent="0" marL="0">
+            <a:pPr marL="0" indent="0">
               <a:buNone/>
             </a:pPr>
             <a:r>
@@ -3815,6 +3632,13 @@
             <a:prstDash val="solid"/>
           </a:ln>
         </p:spPr>
+        <p:txBody>
+          <a:bodyPr/>
+          <a:lstStyle/>
+          <a:p>
+            <a:endParaRPr lang="en-IN"/>
+          </a:p>
+        </p:txBody>
       </p:sp>
       <p:sp>
         <p:nvSpPr>
@@ -3837,7 +3661,7 @@
           <a:bodyPr wrap="square" lIns="0" tIns="0" rIns="0" bIns="0" rtlCol="0" anchor="t"/>
           <a:lstStyle/>
           <a:p>
-            <a:pPr indent="0" marL="0">
+            <a:pPr marL="0" indent="0">
               <a:buNone/>
             </a:pPr>
             <a:r>
@@ -3873,7 +3697,7 @@
           <a:bodyPr wrap="square" lIns="0" tIns="0" rIns="0" bIns="0" rtlCol="0" anchor="t"/>
           <a:lstStyle/>
           <a:p>
-            <a:pPr indent="0" marL="0">
+            <a:pPr marL="0" indent="0">
               <a:buNone/>
             </a:pPr>
             <a:r>
@@ -3914,6 +3738,13 @@
             <a:prstDash val="solid"/>
           </a:ln>
         </p:spPr>
+        <p:txBody>
+          <a:bodyPr/>
+          <a:lstStyle/>
+          <a:p>
+            <a:endParaRPr lang="en-IN"/>
+          </a:p>
+        </p:txBody>
       </p:sp>
       <p:sp>
         <p:nvSpPr>
@@ -3936,7 +3767,7 @@
           <a:bodyPr wrap="square" lIns="0" tIns="0" rIns="0" bIns="0" rtlCol="0" anchor="t"/>
           <a:lstStyle/>
           <a:p>
-            <a:pPr indent="0" marL="0">
+            <a:pPr marL="0" indent="0">
               <a:buNone/>
             </a:pPr>
             <a:r>
@@ -3972,7 +3803,7 @@
           <a:bodyPr wrap="square" lIns="0" tIns="0" rIns="0" bIns="0" rtlCol="0" anchor="t"/>
           <a:lstStyle/>
           <a:p>
-            <a:pPr indent="0" marL="0">
+            <a:pPr marL="0" indent="0">
               <a:buNone/>
             </a:pPr>
             <a:r>
@@ -4007,7 +3838,7 @@
           </a:prstGeom>
           <a:extLst>
             <a:ext uri="{C572A759-6A51-4108-AA02-DFA0A04FC94B}">
-              <ma14:wrappingTextBoxFlag xmlns:ma14="http://schemas.microsoft.com/office/mac/drawingml/2011/main" val="0"/>
+              <ma14:wrappingTextBoxFlag xmlns:ma14="http://schemas.microsoft.com/office/mac/drawingml/2011/main" xmlns="" val="0"/>
             </a:ext>
           </a:extLst>
         </p:spPr>
@@ -4025,7 +3856,7 @@
           <a:p>
             <a:pPr algn="r"/>
             <a:fld id="{F7021451-1387-4CA6-816F-3879F97B5CBC}" type="slidenum">
-              <a:rPr b="0" lang="en-US"/>
+              <a:rPr lang="en-US" b="0"/>
               <a:t>11</a:t>
             </a:fld>
             <a:endParaRPr lang="en-US"/>
@@ -4060,9 +3891,11 @@
       <p:sp>
         <p:nvSpPr>
           <p:cNvPr id="2" name="Text 0"/>
-          <p:cNvSpPr/>
+          <p:cNvSpPr>
+            <a:spLocks noGrp="1"/>
+          </p:cNvSpPr>
           <p:nvPr>
-            <p:ph idx="100" type="body" hasCustomPrompt="1"/>
+            <p:ph type="body" idx="100" hasCustomPrompt="1"/>
           </p:nvPr>
         </p:nvSpPr>
         <p:spPr>
@@ -4080,11 +3913,11 @@
           <a:bodyPr wrap="square" lIns="0" tIns="0" rIns="0" bIns="0" rtlCol="0"/>
           <a:lstStyle/>
           <a:p>
-            <a:pPr indent="0" marL="0">
-              <a:buNone/>
-            </a:pPr>
-            <a:r>
-              <a:rPr lang="en-US" sz="1300" spc="200" kern="0" dirty="0">
+            <a:pPr marL="0" indent="0">
+              <a:buNone/>
+            </a:pPr>
+            <a:r>
+              <a:rPr lang="en-US" sz="1300" kern="0" spc="200" dirty="0">
                 <a:solidFill>
                   <a:schemeClr val="accent1"/>
                 </a:solidFill>
@@ -4101,9 +3934,11 @@
       <p:sp>
         <p:nvSpPr>
           <p:cNvPr id="3" name="Text 0"/>
-          <p:cNvSpPr/>
+          <p:cNvSpPr>
+            <a:spLocks noGrp="1"/>
+          </p:cNvSpPr>
           <p:nvPr>
-            <p:ph idx="101" type="title" hasCustomPrompt="1"/>
+            <p:ph type="title" idx="101" hasCustomPrompt="1"/>
           </p:nvPr>
         </p:nvSpPr>
         <p:spPr>
@@ -4121,7 +3956,7 @@
           <a:bodyPr wrap="square" lIns="0" tIns="0" rIns="0" bIns="0" rtlCol="0" anchor="t"/>
           <a:lstStyle/>
           <a:p>
-            <a:pPr algn="l" indent="0" marL="0">
+            <a:pPr marL="0" indent="0" algn="l">
               <a:buNone/>
             </a:pPr>
             <a:r>
@@ -4152,15 +3987,27 @@
         </p:nvGraphicFramePr>
         <p:xfrm>
           <a:off x="548640" y="1783080"/>
-          <a:ext cx="11094415" cy="914400"/>
+          <a:ext cx="11094415" cy="2468880"/>
         </p:xfrm>
         <a:graphic>
           <a:graphicData uri="http://schemas.openxmlformats.org/drawingml/2006/table">
             <a:tbl>
               <a:tblPr/>
               <a:tblGrid>
-                <a:gridCol w="5120640"/>
-                <a:gridCol w="5973775"/>
+                <a:gridCol w="5120640">
+                  <a:extLst>
+                    <a:ext uri="{9D8B030D-6E8A-4147-A177-3AD203B41FA5}">
+                      <a16:colId xmlns:a16="http://schemas.microsoft.com/office/drawing/2014/main" val="20000"/>
+                    </a:ext>
+                  </a:extLst>
+                </a:gridCol>
+                <a:gridCol w="5973775">
+                  <a:extLst>
+                    <a:ext uri="{9D8B030D-6E8A-4147-A177-3AD203B41FA5}">
+                      <a16:colId xmlns:a16="http://schemas.microsoft.com/office/drawing/2014/main" val="20001"/>
+                    </a:ext>
+                  </a:extLst>
+                </a:gridCol>
               </a:tblGrid>
               <a:tr h="0">
                 <a:tc>
@@ -4168,7 +4015,7 @@
                     <a:bodyPr/>
                     <a:lstStyle/>
                     <a:p>
-                      <a:pPr indent="0" marL="0">
+                      <a:pPr marL="0" indent="0">
                         <a:buNone/>
                       </a:pPr>
                       <a:r>
@@ -4229,7 +4076,7 @@
                     <a:bodyPr/>
                     <a:lstStyle/>
                     <a:p>
-                      <a:pPr indent="0" marL="0">
+                      <a:pPr marL="0" indent="0">
                         <a:buNone/>
                       </a:pPr>
                       <a:r>
@@ -4285,6 +4132,11 @@
                     </a:solidFill>
                   </a:tcPr>
                 </a:tc>
+                <a:extLst>
+                  <a:ext uri="{0D108BD9-81ED-4DB2-BD59-A6C34878D82A}">
+                    <a16:rowId xmlns:a16="http://schemas.microsoft.com/office/drawing/2014/main" val="10000"/>
+                  </a:ext>
+                </a:extLst>
               </a:tr>
               <a:tr h="0">
                 <a:tc>
@@ -4292,7 +4144,7 @@
                     <a:bodyPr/>
                     <a:lstStyle/>
                     <a:p>
-                      <a:pPr indent="0" marL="0">
+                      <a:pPr marL="0" indent="0">
                         <a:buNone/>
                       </a:pPr>
                       <a:r>
@@ -4353,7 +4205,7 @@
                     <a:bodyPr/>
                     <a:lstStyle/>
                     <a:p>
-                      <a:pPr indent="0" marL="0">
+                      <a:pPr marL="0" indent="0">
                         <a:buNone/>
                       </a:pPr>
                       <a:r>
@@ -4409,6 +4261,11 @@
                     </a:solidFill>
                   </a:tcPr>
                 </a:tc>
+                <a:extLst>
+                  <a:ext uri="{0D108BD9-81ED-4DB2-BD59-A6C34878D82A}">
+                    <a16:rowId xmlns:a16="http://schemas.microsoft.com/office/drawing/2014/main" val="10001"/>
+                  </a:ext>
+                </a:extLst>
               </a:tr>
               <a:tr h="0">
                 <a:tc>
@@ -4416,7 +4273,7 @@
                     <a:bodyPr/>
                     <a:lstStyle/>
                     <a:p>
-                      <a:pPr indent="0" marL="0">
+                      <a:pPr marL="0" indent="0">
                         <a:buNone/>
                       </a:pPr>
                       <a:r>
@@ -4477,7 +4334,7 @@
                     <a:bodyPr/>
                     <a:lstStyle/>
                     <a:p>
-                      <a:pPr indent="0" marL="0">
+                      <a:pPr marL="0" indent="0">
                         <a:buNone/>
                       </a:pPr>
                       <a:r>
@@ -4533,6 +4390,11 @@
                     </a:solidFill>
                   </a:tcPr>
                 </a:tc>
+                <a:extLst>
+                  <a:ext uri="{0D108BD9-81ED-4DB2-BD59-A6C34878D82A}">
+                    <a16:rowId xmlns:a16="http://schemas.microsoft.com/office/drawing/2014/main" val="10002"/>
+                  </a:ext>
+                </a:extLst>
               </a:tr>
               <a:tr h="0">
                 <a:tc>
@@ -4540,7 +4402,7 @@
                     <a:bodyPr/>
                     <a:lstStyle/>
                     <a:p>
-                      <a:pPr indent="0" marL="0">
+                      <a:pPr marL="0" indent="0">
                         <a:buNone/>
                       </a:pPr>
                       <a:r>
@@ -4601,7 +4463,7 @@
                     <a:bodyPr/>
                     <a:lstStyle/>
                     <a:p>
-                      <a:pPr indent="0" marL="0">
+                      <a:pPr marL="0" indent="0">
                         <a:buNone/>
                       </a:pPr>
                       <a:r>
@@ -4657,6 +4519,11 @@
                     </a:solidFill>
                   </a:tcPr>
                 </a:tc>
+                <a:extLst>
+                  <a:ext uri="{0D108BD9-81ED-4DB2-BD59-A6C34878D82A}">
+                    <a16:rowId xmlns:a16="http://schemas.microsoft.com/office/drawing/2014/main" val="10003"/>
+                  </a:ext>
+                </a:extLst>
               </a:tr>
               <a:tr h="0">
                 <a:tc>
@@ -4664,7 +4531,7 @@
                     <a:bodyPr/>
                     <a:lstStyle/>
                     <a:p>
-                      <a:pPr indent="0" marL="0">
+                      <a:pPr marL="0" indent="0">
                         <a:buNone/>
                       </a:pPr>
                       <a:r>
@@ -4725,7 +4592,7 @@
                     <a:bodyPr/>
                     <a:lstStyle/>
                     <a:p>
-                      <a:pPr indent="0" marL="0">
+                      <a:pPr marL="0" indent="0">
                         <a:buNone/>
                       </a:pPr>
                       <a:r>
@@ -4781,6 +4648,11 @@
                     </a:solidFill>
                   </a:tcPr>
                 </a:tc>
+                <a:extLst>
+                  <a:ext uri="{0D108BD9-81ED-4DB2-BD59-A6C34878D82A}">
+                    <a16:rowId xmlns:a16="http://schemas.microsoft.com/office/drawing/2014/main" val="10004"/>
+                  </a:ext>
+                </a:extLst>
               </a:tr>
               <a:tr h="0">
                 <a:tc>
@@ -4788,7 +4660,7 @@
                     <a:bodyPr/>
                     <a:lstStyle/>
                     <a:p>
-                      <a:pPr indent="0" marL="0">
+                      <a:pPr marL="0" indent="0">
                         <a:buNone/>
                       </a:pPr>
                       <a:r>
@@ -4849,7 +4721,7 @@
                     <a:bodyPr/>
                     <a:lstStyle/>
                     <a:p>
-                      <a:pPr indent="0" marL="0">
+                      <a:pPr marL="0" indent="0">
                         <a:buNone/>
                       </a:pPr>
                       <a:r>
@@ -4905,6 +4777,11 @@
                     </a:solidFill>
                   </a:tcPr>
                 </a:tc>
+                <a:extLst>
+                  <a:ext uri="{0D108BD9-81ED-4DB2-BD59-A6C34878D82A}">
+                    <a16:rowId xmlns:a16="http://schemas.microsoft.com/office/drawing/2014/main" val="10005"/>
+                  </a:ext>
+                </a:extLst>
               </a:tr>
             </a:tbl>
           </a:graphicData>
@@ -4930,7 +4807,7 @@
           </a:prstGeom>
           <a:extLst>
             <a:ext uri="{C572A759-6A51-4108-AA02-DFA0A04FC94B}">
-              <ma14:wrappingTextBoxFlag xmlns:ma14="http://schemas.microsoft.com/office/mac/drawingml/2011/main" val="0"/>
+              <ma14:wrappingTextBoxFlag xmlns:ma14="http://schemas.microsoft.com/office/mac/drawingml/2011/main" xmlns="" val="0"/>
             </a:ext>
           </a:extLst>
         </p:spPr>
@@ -4948,7 +4825,7 @@
           <a:p>
             <a:pPr algn="r"/>
             <a:fld id="{F7021451-1387-4CA6-816F-3879F97B5CBC}" type="slidenum">
-              <a:rPr b="0" lang="en-US"/>
+              <a:rPr lang="en-US" b="0"/>
               <a:t>12</a:t>
             </a:fld>
             <a:endParaRPr lang="en-US"/>
@@ -4983,9 +4860,11 @@
       <p:sp>
         <p:nvSpPr>
           <p:cNvPr id="2" name="Text 0"/>
-          <p:cNvSpPr/>
+          <p:cNvSpPr>
+            <a:spLocks noGrp="1"/>
+          </p:cNvSpPr>
           <p:nvPr>
-            <p:ph idx="100" type="body" hasCustomPrompt="1"/>
+            <p:ph type="body" idx="100" hasCustomPrompt="1"/>
           </p:nvPr>
         </p:nvSpPr>
         <p:spPr>
@@ -5003,11 +4882,11 @@
           <a:bodyPr wrap="square" lIns="0" tIns="0" rIns="0" bIns="0" rtlCol="0"/>
           <a:lstStyle/>
           <a:p>
-            <a:pPr indent="0" marL="0">
-              <a:buNone/>
-            </a:pPr>
-            <a:r>
-              <a:rPr lang="en-US" sz="1300" spc="200" kern="0" dirty="0">
+            <a:pPr marL="0" indent="0">
+              <a:buNone/>
+            </a:pPr>
+            <a:r>
+              <a:rPr lang="en-US" sz="1300" kern="0" spc="200" dirty="0">
                 <a:solidFill>
                   <a:schemeClr val="accent1"/>
                 </a:solidFill>
@@ -5024,9 +4903,11 @@
       <p:sp>
         <p:nvSpPr>
           <p:cNvPr id="3" name="Text 0"/>
-          <p:cNvSpPr/>
+          <p:cNvSpPr>
+            <a:spLocks noGrp="1"/>
+          </p:cNvSpPr>
           <p:nvPr>
-            <p:ph idx="101" type="title" hasCustomPrompt="1"/>
+            <p:ph type="title" idx="101" hasCustomPrompt="1"/>
           </p:nvPr>
         </p:nvSpPr>
         <p:spPr>
@@ -5044,7 +4925,7 @@
           <a:bodyPr wrap="square" lIns="0" tIns="0" rIns="0" bIns="0" rtlCol="0" anchor="t"/>
           <a:lstStyle/>
           <a:p>
-            <a:pPr algn="l" indent="0" marL="0">
+            <a:pPr marL="0" indent="0" algn="l">
               <a:buNone/>
             </a:pPr>
             <a:r>
@@ -5085,6 +4966,13 @@
             <a:prstDash val="solid"/>
           </a:ln>
         </p:spPr>
+        <p:txBody>
+          <a:bodyPr/>
+          <a:lstStyle/>
+          <a:p>
+            <a:endParaRPr lang="en-IN"/>
+          </a:p>
+        </p:txBody>
       </p:sp>
       <p:sp>
         <p:nvSpPr>
@@ -5107,7 +4995,7 @@
           <a:bodyPr wrap="square" lIns="0" tIns="0" rIns="0" bIns="0" rtlCol="0" anchor="t"/>
           <a:lstStyle/>
           <a:p>
-            <a:pPr indent="0" marL="0">
+            <a:pPr marL="0" indent="0">
               <a:buNone/>
             </a:pPr>
             <a:r>
@@ -5260,6 +5148,13 @@
             <a:prstDash val="solid"/>
           </a:ln>
         </p:spPr>
+        <p:txBody>
+          <a:bodyPr/>
+          <a:lstStyle/>
+          <a:p>
+            <a:endParaRPr lang="en-IN"/>
+          </a:p>
+        </p:txBody>
       </p:sp>
       <p:sp>
         <p:nvSpPr>
@@ -5282,7 +5177,7 @@
           <a:bodyPr wrap="square" lIns="0" tIns="0" rIns="0" bIns="0" rtlCol="0" anchor="t"/>
           <a:lstStyle/>
           <a:p>
-            <a:pPr indent="0" marL="0">
+            <a:pPr marL="0" indent="0">
               <a:buNone/>
             </a:pPr>
             <a:r>
@@ -5429,7 +5324,7 @@
           </a:prstGeom>
           <a:extLst>
             <a:ext uri="{C572A759-6A51-4108-AA02-DFA0A04FC94B}">
-              <ma14:wrappingTextBoxFlag xmlns:ma14="http://schemas.microsoft.com/office/mac/drawingml/2011/main" val="0"/>
+              <ma14:wrappingTextBoxFlag xmlns:ma14="http://schemas.microsoft.com/office/mac/drawingml/2011/main" xmlns="" val="0"/>
             </a:ext>
           </a:extLst>
         </p:spPr>
@@ -5447,7 +5342,7 @@
           <a:p>
             <a:pPr algn="r"/>
             <a:fld id="{F7021451-1387-4CA6-816F-3879F97B5CBC}" type="slidenum">
-              <a:rPr b="0" lang="en-US"/>
+              <a:rPr lang="en-US" b="0"/>
               <a:t>13</a:t>
             </a:fld>
             <a:endParaRPr lang="en-US"/>
@@ -5482,9 +5377,11 @@
       <p:sp>
         <p:nvSpPr>
           <p:cNvPr id="2" name="Text 0"/>
-          <p:cNvSpPr/>
+          <p:cNvSpPr>
+            <a:spLocks noGrp="1"/>
+          </p:cNvSpPr>
           <p:nvPr>
-            <p:ph idx="100" type="body" hasCustomPrompt="1"/>
+            <p:ph type="body" idx="100" hasCustomPrompt="1"/>
           </p:nvPr>
         </p:nvSpPr>
         <p:spPr>
@@ -5502,11 +5399,11 @@
           <a:bodyPr wrap="square" lIns="0" tIns="0" rIns="0" bIns="0" rtlCol="0"/>
           <a:lstStyle/>
           <a:p>
-            <a:pPr indent="0" marL="0">
-              <a:buNone/>
-            </a:pPr>
-            <a:r>
-              <a:rPr lang="en-US" sz="1300" spc="200" kern="0" dirty="0">
+            <a:pPr marL="0" indent="0">
+              <a:buNone/>
+            </a:pPr>
+            <a:r>
+              <a:rPr lang="en-US" sz="1300" kern="0" spc="200" dirty="0">
                 <a:solidFill>
                   <a:schemeClr val="accent5"/>
                 </a:solidFill>
@@ -5541,7 +5438,7 @@
           <a:bodyPr wrap="square" lIns="0" tIns="0" rIns="0" bIns="0" rtlCol="0" anchor="t"/>
           <a:lstStyle/>
           <a:p>
-            <a:pPr indent="0" marL="0">
+            <a:pPr marL="0" indent="0">
               <a:buNone/>
             </a:pPr>
             <a:r>
@@ -5577,16 +5474,13 @@
           <a:bodyPr wrap="square" lIns="0" tIns="0" rIns="0" bIns="0" rtlCol="0" anchor="t"/>
           <a:lstStyle/>
           <a:p>
-            <a:pPr indent="0" marL="0">
-              <a:buNone/>
-            </a:pPr>
             <a:r>
               <a:rPr lang="en-US" sz="1600" dirty="0">
                 <a:solidFill>
                   <a:schemeClr val="accent6"/>
                 </a:solidFill>
               </a:rPr>
-              <a:t>Code: [github.com/your-username/dataops-pipeline]</a:t>
+              <a:t>Code: https://github.com/ramjishree305-beep/Coventry-Building-Society----Dataops-Pipeline</a:t>
             </a:r>
             <a:endParaRPr lang="en-US" sz="1600" dirty="0"/>
           </a:p>
@@ -5613,6 +5507,13 @@
           </a:solidFill>
           <a:ln/>
         </p:spPr>
+        <p:txBody>
+          <a:bodyPr/>
+          <a:lstStyle/>
+          <a:p>
+            <a:endParaRPr lang="en-IN"/>
+          </a:p>
+        </p:txBody>
       </p:sp>
       <p:sp>
         <p:nvSpPr>
@@ -5635,7 +5536,7 @@
           <a:bodyPr wrap="square" lIns="0" tIns="0" rIns="0" bIns="0" rtlCol="0" anchor="t"/>
           <a:lstStyle/>
           <a:p>
-            <a:pPr indent="0" marL="0">
+            <a:pPr marL="0" indent="0">
               <a:spcAft>
                 <a:spcPts val="1400"/>
               </a:spcAft>
@@ -5655,7 +5556,7 @@
             <a:endParaRPr lang="en-US" sz="1700" dirty="0"/>
           </a:p>
           <a:p>
-            <a:pPr indent="0" marL="0">
+            <a:pPr marL="0" indent="0">
               <a:spcAft>
                 <a:spcPts val="1400"/>
               </a:spcAft>
@@ -5675,7 +5576,7 @@
             <a:endParaRPr lang="en-US" sz="1700" dirty="0"/>
           </a:p>
           <a:p>
-            <a:pPr indent="0" marL="0">
+            <a:pPr marL="0" indent="0">
               <a:spcAft>
                 <a:spcPts val="1400"/>
               </a:spcAft>
@@ -5695,7 +5596,7 @@
             <a:endParaRPr lang="en-US" sz="1700" dirty="0"/>
           </a:p>
           <a:p>
-            <a:pPr indent="0" marL="0">
+            <a:pPr marL="0" indent="0">
               <a:spcAft>
                 <a:spcPts val="1400"/>
               </a:spcAft>
@@ -5715,7 +5616,7 @@
             <a:endParaRPr lang="en-US" sz="1700" dirty="0"/>
           </a:p>
           <a:p>
-            <a:pPr indent="0" marL="0">
+            <a:pPr marL="0" indent="0">
               <a:spcAft>
                 <a:spcPts val="1400"/>
               </a:spcAft>
@@ -5735,7 +5636,7 @@
             <a:endParaRPr lang="en-US" sz="1700" dirty="0"/>
           </a:p>
           <a:p>
-            <a:pPr indent="0" marL="0">
+            <a:pPr marL="0" indent="0">
               <a:spcAft>
                 <a:spcPts val="1400"/>
               </a:spcAft>
@@ -5753,36 +5654,6 @@
               <a:t>6  green GitHub Actions run</a:t>
             </a:r>
             <a:endParaRPr lang="en-US" sz="1700" dirty="0"/>
-          </a:p>
-        </p:txBody>
-      </p:sp>
-      <p:sp>
-        <p:nvSpPr>
-          <p:cNvPr id="8" name="Text 0"/>
-          <p:cNvSpPr/>
-          <p:nvPr>
-            <p:ph idx="101" type="title" hasCustomPrompt="1"/>
-          </p:nvPr>
-        </p:nvSpPr>
-        <p:spPr>
-          <a:xfrm>
-            <a:off x="548640" y="731520"/>
-            <a:ext cx="11094415" cy="1280160"/>
-          </a:xfrm>
-          <a:prstGeom prst="rect">
-            <a:avLst/>
-          </a:prstGeom>
-          <a:noFill/>
-          <a:ln/>
-        </p:spPr>
-        <p:txBody>
-          <a:bodyPr wrap="square" lIns="0" tIns="0" rIns="0" bIns="0" rtlCol="0" anchor="t"/>
-          <a:lstStyle/>
-          <a:p>
-            <a:pPr algn="l" indent="0" marL="0">
-              <a:buNone/>
-            </a:pPr>
-            <a:endParaRPr lang="en-US" sz="3600" dirty="0"/>
           </a:p>
         </p:txBody>
       </p:sp>
@@ -5806,7 +5677,7 @@
           </a:prstGeom>
           <a:extLst>
             <a:ext uri="{C572A759-6A51-4108-AA02-DFA0A04FC94B}">
-              <ma14:wrappingTextBoxFlag xmlns:ma14="http://schemas.microsoft.com/office/mac/drawingml/2011/main" val="0"/>
+              <ma14:wrappingTextBoxFlag xmlns:ma14="http://schemas.microsoft.com/office/mac/drawingml/2011/main" xmlns="" val="0"/>
             </a:ext>
           </a:extLst>
         </p:spPr>
@@ -5824,7 +5695,7 @@
           <a:p>
             <a:pPr algn="r"/>
             <a:fld id="{F7021451-1387-4CA6-816F-3879F97B5CBC}" type="slidenum">
-              <a:rPr b="0" lang="en-US"/>
+              <a:rPr lang="en-US" b="0"/>
               <a:t>14</a:t>
             </a:fld>
             <a:endParaRPr lang="en-US"/>
@@ -5859,9 +5730,11 @@
       <p:sp>
         <p:nvSpPr>
           <p:cNvPr id="2" name="Text 0"/>
-          <p:cNvSpPr/>
+          <p:cNvSpPr>
+            <a:spLocks noGrp="1"/>
+          </p:cNvSpPr>
           <p:nvPr>
-            <p:ph idx="100" type="body" hasCustomPrompt="1"/>
+            <p:ph type="body" idx="100" hasCustomPrompt="1"/>
           </p:nvPr>
         </p:nvSpPr>
         <p:spPr>
@@ -5879,11 +5752,11 @@
           <a:bodyPr wrap="square" lIns="0" tIns="0" rIns="0" bIns="0" rtlCol="0"/>
           <a:lstStyle/>
           <a:p>
-            <a:pPr indent="0" marL="0">
-              <a:buNone/>
-            </a:pPr>
-            <a:r>
-              <a:rPr lang="en-US" sz="1300" spc="200" kern="0" dirty="0">
+            <a:pPr marL="0" indent="0">
+              <a:buNone/>
+            </a:pPr>
+            <a:r>
+              <a:rPr lang="en-US" sz="1300" kern="0" spc="200" dirty="0">
                 <a:solidFill>
                   <a:schemeClr val="accent1"/>
                 </a:solidFill>
@@ -5900,9 +5773,11 @@
       <p:sp>
         <p:nvSpPr>
           <p:cNvPr id="3" name="Text 0"/>
-          <p:cNvSpPr/>
+          <p:cNvSpPr>
+            <a:spLocks noGrp="1"/>
+          </p:cNvSpPr>
           <p:nvPr>
-            <p:ph idx="101" type="title" hasCustomPrompt="1"/>
+            <p:ph type="title" idx="101" hasCustomPrompt="1"/>
           </p:nvPr>
         </p:nvSpPr>
         <p:spPr>
@@ -5920,7 +5795,7 @@
           <a:bodyPr wrap="square" lIns="0" tIns="0" rIns="0" bIns="0" rtlCol="0" anchor="t"/>
           <a:lstStyle/>
           <a:p>
-            <a:pPr algn="l" indent="0" marL="0">
+            <a:pPr marL="0" indent="0" algn="l">
               <a:buNone/>
             </a:pPr>
             <a:r>
@@ -5937,7 +5812,7 @@
       </p:sp>
       <p:graphicFrame>
         <p:nvGraphicFramePr>
-          <p:cNvPr id="3" name="Table 0"/>
+          <p:cNvPr id="4" name="Table 0"/>
           <p:cNvGraphicFramePr>
             <a:graphicFrameLocks noGrp="1"/>
           </p:cNvGraphicFramePr>
@@ -5951,15 +5826,27 @@
         </p:nvGraphicFramePr>
         <p:xfrm>
           <a:off x="548640" y="1783080"/>
-          <a:ext cx="11094415" cy="914400"/>
+          <a:ext cx="11094415" cy="2966720"/>
         </p:xfrm>
         <a:graphic>
           <a:graphicData uri="http://schemas.openxmlformats.org/drawingml/2006/table">
             <a:tbl>
               <a:tblPr/>
               <a:tblGrid>
-                <a:gridCol w="2743200"/>
-                <a:gridCol w="8351215"/>
+                <a:gridCol w="2743200">
+                  <a:extLst>
+                    <a:ext uri="{9D8B030D-6E8A-4147-A177-3AD203B41FA5}">
+                      <a16:colId xmlns:a16="http://schemas.microsoft.com/office/drawing/2014/main" val="20000"/>
+                    </a:ext>
+                  </a:extLst>
+                </a:gridCol>
+                <a:gridCol w="8351215">
+                  <a:extLst>
+                    <a:ext uri="{9D8B030D-6E8A-4147-A177-3AD203B41FA5}">
+                      <a16:colId xmlns:a16="http://schemas.microsoft.com/office/drawing/2014/main" val="20001"/>
+                    </a:ext>
+                  </a:extLst>
+                </a:gridCol>
               </a:tblGrid>
               <a:tr h="0">
                 <a:tc>
@@ -5967,7 +5854,7 @@
                     <a:bodyPr/>
                     <a:lstStyle/>
                     <a:p>
-                      <a:pPr indent="0" marL="0">
+                      <a:pPr marL="0" indent="0">
                         <a:buNone/>
                       </a:pPr>
                       <a:r>
@@ -6028,7 +5915,7 @@
                     <a:bodyPr/>
                     <a:lstStyle/>
                     <a:p>
-                      <a:pPr indent="0" marL="0">
+                      <a:pPr marL="0" indent="0">
                         <a:buNone/>
                       </a:pPr>
                       <a:r>
@@ -6084,6 +5971,11 @@
                     </a:solidFill>
                   </a:tcPr>
                 </a:tc>
+                <a:extLst>
+                  <a:ext uri="{0D108BD9-81ED-4DB2-BD59-A6C34878D82A}">
+                    <a16:rowId xmlns:a16="http://schemas.microsoft.com/office/drawing/2014/main" val="10000"/>
+                  </a:ext>
+                </a:extLst>
               </a:tr>
               <a:tr h="0">
                 <a:tc>
@@ -6091,7 +5983,7 @@
                     <a:bodyPr/>
                     <a:lstStyle/>
                     <a:p>
-                      <a:pPr indent="0" marL="0">
+                      <a:pPr marL="0" indent="0">
                         <a:buNone/>
                       </a:pPr>
                       <a:r>
@@ -6152,7 +6044,7 @@
                     <a:bodyPr/>
                     <a:lstStyle/>
                     <a:p>
-                      <a:pPr indent="0" marL="0">
+                      <a:pPr marL="0" indent="0">
                         <a:buNone/>
                       </a:pPr>
                       <a:r>
@@ -6208,6 +6100,11 @@
                     </a:solidFill>
                   </a:tcPr>
                 </a:tc>
+                <a:extLst>
+                  <a:ext uri="{0D108BD9-81ED-4DB2-BD59-A6C34878D82A}">
+                    <a16:rowId xmlns:a16="http://schemas.microsoft.com/office/drawing/2014/main" val="10001"/>
+                  </a:ext>
+                </a:extLst>
               </a:tr>
               <a:tr h="0">
                 <a:tc>
@@ -6215,7 +6112,7 @@
                     <a:bodyPr/>
                     <a:lstStyle/>
                     <a:p>
-                      <a:pPr indent="0" marL="0">
+                      <a:pPr marL="0" indent="0">
                         <a:buNone/>
                       </a:pPr>
                       <a:r>
@@ -6276,7 +6173,7 @@
                     <a:bodyPr/>
                     <a:lstStyle/>
                     <a:p>
-                      <a:pPr indent="0" marL="0">
+                      <a:pPr marL="0" indent="0">
                         <a:buNone/>
                       </a:pPr>
                       <a:r>
@@ -6332,6 +6229,11 @@
                     </a:solidFill>
                   </a:tcPr>
                 </a:tc>
+                <a:extLst>
+                  <a:ext uri="{0D108BD9-81ED-4DB2-BD59-A6C34878D82A}">
+                    <a16:rowId xmlns:a16="http://schemas.microsoft.com/office/drawing/2014/main" val="10002"/>
+                  </a:ext>
+                </a:extLst>
               </a:tr>
               <a:tr h="0">
                 <a:tc>
@@ -6339,7 +6241,7 @@
                     <a:bodyPr/>
                     <a:lstStyle/>
                     <a:p>
-                      <a:pPr indent="0" marL="0">
+                      <a:pPr marL="0" indent="0">
                         <a:buNone/>
                       </a:pPr>
                       <a:r>
@@ -6400,7 +6302,7 @@
                     <a:bodyPr/>
                     <a:lstStyle/>
                     <a:p>
-                      <a:pPr indent="0" marL="0">
+                      <a:pPr marL="0" indent="0">
                         <a:buNone/>
                       </a:pPr>
                       <a:r>
@@ -6456,6 +6358,11 @@
                     </a:solidFill>
                   </a:tcPr>
                 </a:tc>
+                <a:extLst>
+                  <a:ext uri="{0D108BD9-81ED-4DB2-BD59-A6C34878D82A}">
+                    <a16:rowId xmlns:a16="http://schemas.microsoft.com/office/drawing/2014/main" val="10003"/>
+                  </a:ext>
+                </a:extLst>
               </a:tr>
               <a:tr h="0">
                 <a:tc>
@@ -6463,7 +6370,7 @@
                     <a:bodyPr/>
                     <a:lstStyle/>
                     <a:p>
-                      <a:pPr indent="0" marL="0">
+                      <a:pPr marL="0" indent="0">
                         <a:buNone/>
                       </a:pPr>
                       <a:r>
@@ -6524,7 +6431,7 @@
                     <a:bodyPr/>
                     <a:lstStyle/>
                     <a:p>
-                      <a:pPr indent="0" marL="0">
+                      <a:pPr marL="0" indent="0">
                         <a:buNone/>
                       </a:pPr>
                       <a:r>
@@ -6580,6 +6487,11 @@
                     </a:solidFill>
                   </a:tcPr>
                 </a:tc>
+                <a:extLst>
+                  <a:ext uri="{0D108BD9-81ED-4DB2-BD59-A6C34878D82A}">
+                    <a16:rowId xmlns:a16="http://schemas.microsoft.com/office/drawing/2014/main" val="10004"/>
+                  </a:ext>
+                </a:extLst>
               </a:tr>
               <a:tr h="0">
                 <a:tc>
@@ -6587,7 +6499,7 @@
                     <a:bodyPr/>
                     <a:lstStyle/>
                     <a:p>
-                      <a:pPr indent="0" marL="0">
+                      <a:pPr marL="0" indent="0">
                         <a:buNone/>
                       </a:pPr>
                       <a:r>
@@ -6648,7 +6560,7 @@
                     <a:bodyPr/>
                     <a:lstStyle/>
                     <a:p>
-                      <a:pPr indent="0" marL="0">
+                      <a:pPr marL="0" indent="0">
                         <a:buNone/>
                       </a:pPr>
                       <a:r>
@@ -6704,6 +6616,11 @@
                     </a:solidFill>
                   </a:tcPr>
                 </a:tc>
+                <a:extLst>
+                  <a:ext uri="{0D108BD9-81ED-4DB2-BD59-A6C34878D82A}">
+                    <a16:rowId xmlns:a16="http://schemas.microsoft.com/office/drawing/2014/main" val="10005"/>
+                  </a:ext>
+                </a:extLst>
               </a:tr>
               <a:tr h="0">
                 <a:tc>
@@ -6711,7 +6628,7 @@
                     <a:bodyPr/>
                     <a:lstStyle/>
                     <a:p>
-                      <a:pPr indent="0" marL="0">
+                      <a:pPr marL="0" indent="0">
                         <a:buNone/>
                       </a:pPr>
                       <a:r>
@@ -6772,7 +6689,7 @@
                     <a:bodyPr/>
                     <a:lstStyle/>
                     <a:p>
-                      <a:pPr indent="0" marL="0">
+                      <a:pPr marL="0" indent="0">
                         <a:buNone/>
                       </a:pPr>
                       <a:r>
@@ -6828,6 +6745,11 @@
                     </a:solidFill>
                   </a:tcPr>
                 </a:tc>
+                <a:extLst>
+                  <a:ext uri="{0D108BD9-81ED-4DB2-BD59-A6C34878D82A}">
+                    <a16:rowId xmlns:a16="http://schemas.microsoft.com/office/drawing/2014/main" val="10006"/>
+                  </a:ext>
+                </a:extLst>
               </a:tr>
               <a:tr h="0">
                 <a:tc>
@@ -6835,7 +6757,7 @@
                     <a:bodyPr/>
                     <a:lstStyle/>
                     <a:p>
-                      <a:pPr indent="0" marL="0">
+                      <a:pPr marL="0" indent="0">
                         <a:buNone/>
                       </a:pPr>
                       <a:r>
@@ -6896,7 +6818,7 @@
                     <a:bodyPr/>
                     <a:lstStyle/>
                     <a:p>
-                      <a:pPr indent="0" marL="0">
+                      <a:pPr marL="0" indent="0">
                         <a:buNone/>
                       </a:pPr>
                       <a:r>
@@ -6952,6 +6874,11 @@
                     </a:solidFill>
                   </a:tcPr>
                 </a:tc>
+                <a:extLst>
+                  <a:ext uri="{0D108BD9-81ED-4DB2-BD59-A6C34878D82A}">
+                    <a16:rowId xmlns:a16="http://schemas.microsoft.com/office/drawing/2014/main" val="10007"/>
+                  </a:ext>
+                </a:extLst>
               </a:tr>
             </a:tbl>
           </a:graphicData>
@@ -6977,7 +6904,7 @@
           </a:prstGeom>
           <a:extLst>
             <a:ext uri="{C572A759-6A51-4108-AA02-DFA0A04FC94B}">
-              <ma14:wrappingTextBoxFlag xmlns:ma14="http://schemas.microsoft.com/office/mac/drawingml/2011/main" val="0"/>
+              <ma14:wrappingTextBoxFlag xmlns:ma14="http://schemas.microsoft.com/office/mac/drawingml/2011/main" xmlns="" val="0"/>
             </a:ext>
           </a:extLst>
         </p:spPr>
@@ -6995,7 +6922,7 @@
           <a:p>
             <a:pPr algn="r"/>
             <a:fld id="{F7021451-1387-4CA6-816F-3879F97B5CBC}" type="slidenum">
-              <a:rPr b="0" lang="en-US"/>
+              <a:rPr lang="en-US" b="0"/>
               <a:t>2</a:t>
             </a:fld>
             <a:endParaRPr lang="en-US"/>
@@ -7030,9 +6957,11 @@
       <p:sp>
         <p:nvSpPr>
           <p:cNvPr id="2" name="Text 0"/>
-          <p:cNvSpPr/>
+          <p:cNvSpPr>
+            <a:spLocks noGrp="1"/>
+          </p:cNvSpPr>
           <p:nvPr>
-            <p:ph idx="100" type="body" hasCustomPrompt="1"/>
+            <p:ph type="body" idx="100" hasCustomPrompt="1"/>
           </p:nvPr>
         </p:nvSpPr>
         <p:spPr>
@@ -7050,11 +6979,11 @@
           <a:bodyPr wrap="square" lIns="0" tIns="0" rIns="0" bIns="0" rtlCol="0"/>
           <a:lstStyle/>
           <a:p>
-            <a:pPr indent="0" marL="0">
-              <a:buNone/>
-            </a:pPr>
-            <a:r>
-              <a:rPr lang="en-US" sz="1300" spc="200" kern="0" dirty="0">
+            <a:pPr marL="0" indent="0">
+              <a:buNone/>
+            </a:pPr>
+            <a:r>
+              <a:rPr lang="en-US" sz="1300" kern="0" spc="200" dirty="0">
                 <a:solidFill>
                   <a:schemeClr val="accent1"/>
                 </a:solidFill>
@@ -7071,9 +7000,11 @@
       <p:sp>
         <p:nvSpPr>
           <p:cNvPr id="3" name="Text 0"/>
-          <p:cNvSpPr/>
+          <p:cNvSpPr>
+            <a:spLocks noGrp="1"/>
+          </p:cNvSpPr>
           <p:nvPr>
-            <p:ph idx="101" type="title" hasCustomPrompt="1"/>
+            <p:ph type="title" idx="101" hasCustomPrompt="1"/>
           </p:nvPr>
         </p:nvSpPr>
         <p:spPr>
@@ -7091,7 +7022,7 @@
           <a:bodyPr wrap="square" lIns="0" tIns="0" rIns="0" bIns="0" rtlCol="0" anchor="t"/>
           <a:lstStyle/>
           <a:p>
-            <a:pPr algn="l" indent="0" marL="0">
+            <a:pPr marL="0" indent="0" algn="l">
               <a:buNone/>
             </a:pPr>
             <a:r>
@@ -7132,6 +7063,13 @@
             <a:prstDash val="solid"/>
           </a:ln>
         </p:spPr>
+        <p:txBody>
+          <a:bodyPr/>
+          <a:lstStyle/>
+          <a:p>
+            <a:endParaRPr lang="en-IN"/>
+          </a:p>
+        </p:txBody>
       </p:sp>
       <p:sp>
         <p:nvSpPr>
@@ -7154,7 +7092,7 @@
           <a:bodyPr wrap="square" lIns="0" tIns="0" rIns="0" bIns="0" rtlCol="0" anchor="t"/>
           <a:lstStyle/>
           <a:p>
-            <a:pPr indent="0" marL="0">
+            <a:pPr marL="0" indent="0">
               <a:buNone/>
             </a:pPr>
             <a:r>
@@ -7190,7 +7128,7 @@
           <a:bodyPr wrap="square" lIns="0" tIns="0" rIns="0" bIns="0" rtlCol="0" anchor="t"/>
           <a:lstStyle/>
           <a:p>
-            <a:pPr indent="0" marL="0">
+            <a:pPr marL="0" indent="0">
               <a:buNone/>
             </a:pPr>
             <a:r>
@@ -7228,6 +7166,13 @@
             <a:tailEnd type="triangle"/>
           </a:ln>
         </p:spPr>
+        <p:txBody>
+          <a:bodyPr/>
+          <a:lstStyle/>
+          <a:p>
+            <a:endParaRPr lang="en-IN"/>
+          </a:p>
+        </p:txBody>
       </p:sp>
       <p:sp>
         <p:nvSpPr>
@@ -7255,6 +7200,13 @@
             <a:prstDash val="solid"/>
           </a:ln>
         </p:spPr>
+        <p:txBody>
+          <a:bodyPr/>
+          <a:lstStyle/>
+          <a:p>
+            <a:endParaRPr lang="en-IN"/>
+          </a:p>
+        </p:txBody>
       </p:sp>
       <p:sp>
         <p:nvSpPr>
@@ -7277,7 +7229,7 @@
           <a:bodyPr wrap="square" lIns="0" tIns="0" rIns="0" bIns="0" rtlCol="0" anchor="t"/>
           <a:lstStyle/>
           <a:p>
-            <a:pPr indent="0" marL="0">
+            <a:pPr marL="0" indent="0">
               <a:buNone/>
             </a:pPr>
             <a:r>
@@ -7313,7 +7265,7 @@
           <a:bodyPr wrap="square" lIns="0" tIns="0" rIns="0" bIns="0" rtlCol="0" anchor="t"/>
           <a:lstStyle/>
           <a:p>
-            <a:pPr indent="0" marL="0">
+            <a:pPr marL="0" indent="0">
               <a:buNone/>
             </a:pPr>
             <a:r>
@@ -7351,6 +7303,13 @@
             <a:tailEnd type="triangle"/>
           </a:ln>
         </p:spPr>
+        <p:txBody>
+          <a:bodyPr/>
+          <a:lstStyle/>
+          <a:p>
+            <a:endParaRPr lang="en-IN"/>
+          </a:p>
+        </p:txBody>
       </p:sp>
       <p:sp>
         <p:nvSpPr>
@@ -7378,6 +7337,13 @@
             <a:prstDash val="solid"/>
           </a:ln>
         </p:spPr>
+        <p:txBody>
+          <a:bodyPr/>
+          <a:lstStyle/>
+          <a:p>
+            <a:endParaRPr lang="en-IN"/>
+          </a:p>
+        </p:txBody>
       </p:sp>
       <p:sp>
         <p:nvSpPr>
@@ -7400,7 +7366,7 @@
           <a:bodyPr wrap="square" lIns="0" tIns="0" rIns="0" bIns="0" rtlCol="0" anchor="t"/>
           <a:lstStyle/>
           <a:p>
-            <a:pPr indent="0" marL="0">
+            <a:pPr marL="0" indent="0">
               <a:buNone/>
             </a:pPr>
             <a:r>
@@ -7436,7 +7402,7 @@
           <a:bodyPr wrap="square" lIns="0" tIns="0" rIns="0" bIns="0" rtlCol="0" anchor="t"/>
           <a:lstStyle/>
           <a:p>
-            <a:pPr indent="0" marL="0">
+            <a:pPr marL="0" indent="0">
               <a:buNone/>
             </a:pPr>
             <a:r>
@@ -7474,6 +7440,13 @@
             <a:tailEnd type="triangle"/>
           </a:ln>
         </p:spPr>
+        <p:txBody>
+          <a:bodyPr/>
+          <a:lstStyle/>
+          <a:p>
+            <a:endParaRPr lang="en-IN"/>
+          </a:p>
+        </p:txBody>
       </p:sp>
       <p:sp>
         <p:nvSpPr>
@@ -7501,6 +7474,13 @@
             <a:prstDash val="solid"/>
           </a:ln>
         </p:spPr>
+        <p:txBody>
+          <a:bodyPr/>
+          <a:lstStyle/>
+          <a:p>
+            <a:endParaRPr lang="en-IN"/>
+          </a:p>
+        </p:txBody>
       </p:sp>
       <p:sp>
         <p:nvSpPr>
@@ -7523,7 +7503,7 @@
           <a:bodyPr wrap="square" lIns="0" tIns="0" rIns="0" bIns="0" rtlCol="0" anchor="t"/>
           <a:lstStyle/>
           <a:p>
-            <a:pPr indent="0" marL="0">
+            <a:pPr marL="0" indent="0">
               <a:buNone/>
             </a:pPr>
             <a:r>
@@ -7559,7 +7539,7 @@
           <a:bodyPr wrap="square" lIns="0" tIns="0" rIns="0" bIns="0" rtlCol="0" anchor="t"/>
           <a:lstStyle/>
           <a:p>
-            <a:pPr indent="0" marL="0">
+            <a:pPr marL="0" indent="0">
               <a:buNone/>
             </a:pPr>
             <a:r>
@@ -7597,6 +7577,13 @@
             <a:tailEnd type="triangle"/>
           </a:ln>
         </p:spPr>
+        <p:txBody>
+          <a:bodyPr/>
+          <a:lstStyle/>
+          <a:p>
+            <a:endParaRPr lang="en-IN"/>
+          </a:p>
+        </p:txBody>
       </p:sp>
       <p:sp>
         <p:nvSpPr>
@@ -7624,6 +7611,13 @@
             <a:prstDash val="solid"/>
           </a:ln>
         </p:spPr>
+        <p:txBody>
+          <a:bodyPr/>
+          <a:lstStyle/>
+          <a:p>
+            <a:endParaRPr lang="en-IN"/>
+          </a:p>
+        </p:txBody>
       </p:sp>
       <p:sp>
         <p:nvSpPr>
@@ -7646,7 +7640,7 @@
           <a:bodyPr wrap="square" lIns="0" tIns="0" rIns="0" bIns="0" rtlCol="0" anchor="t"/>
           <a:lstStyle/>
           <a:p>
-            <a:pPr indent="0" marL="0">
+            <a:pPr marL="0" indent="0">
               <a:buNone/>
             </a:pPr>
             <a:r>
@@ -7682,7 +7676,7 @@
           <a:bodyPr wrap="square" lIns="0" tIns="0" rIns="0" bIns="0" rtlCol="0" anchor="t"/>
           <a:lstStyle/>
           <a:p>
-            <a:pPr indent="0" marL="0">
+            <a:pPr marL="0" indent="0">
               <a:buNone/>
             </a:pPr>
             <a:r>
@@ -7720,6 +7714,13 @@
             <a:tailEnd type="triangle"/>
           </a:ln>
         </p:spPr>
+        <p:txBody>
+          <a:bodyPr/>
+          <a:lstStyle/>
+          <a:p>
+            <a:endParaRPr lang="en-IN"/>
+          </a:p>
+        </p:txBody>
       </p:sp>
       <p:sp>
         <p:nvSpPr>
@@ -7742,6 +7743,13 @@
           </a:solidFill>
           <a:ln/>
         </p:spPr>
+        <p:txBody>
+          <a:bodyPr/>
+          <a:lstStyle/>
+          <a:p>
+            <a:endParaRPr lang="en-IN"/>
+          </a:p>
+        </p:txBody>
       </p:sp>
       <p:sp>
         <p:nvSpPr>
@@ -7764,7 +7772,7 @@
           <a:bodyPr wrap="square" lIns="0" tIns="0" rIns="0" bIns="0" rtlCol="0" anchor="t"/>
           <a:lstStyle/>
           <a:p>
-            <a:pPr indent="0" marL="0">
+            <a:pPr marL="0" indent="0">
               <a:buNone/>
             </a:pPr>
             <a:r>
@@ -7800,7 +7808,7 @@
           <a:bodyPr wrap="square" lIns="0" tIns="0" rIns="0" bIns="0" rtlCol="0" anchor="t"/>
           <a:lstStyle/>
           <a:p>
-            <a:pPr indent="0" marL="0">
+            <a:pPr marL="0" indent="0">
               <a:buNone/>
             </a:pPr>
             <a:r>
@@ -7836,6 +7844,13 @@
           </a:solidFill>
           <a:ln/>
         </p:spPr>
+        <p:txBody>
+          <a:bodyPr/>
+          <a:lstStyle/>
+          <a:p>
+            <a:endParaRPr lang="en-IN"/>
+          </a:p>
+        </p:txBody>
       </p:sp>
       <p:sp>
         <p:nvSpPr>
@@ -7858,7 +7873,7 @@
           <a:bodyPr wrap="square" lIns="0" tIns="0" rIns="0" bIns="0" rtlCol="0" anchor="t"/>
           <a:lstStyle/>
           <a:p>
-            <a:pPr indent="0" marL="0">
+            <a:pPr marL="0" indent="0">
               <a:buNone/>
             </a:pPr>
             <a:r>
@@ -7894,7 +7909,7 @@
           <a:bodyPr wrap="square" lIns="0" tIns="0" rIns="0" bIns="0" rtlCol="0" anchor="t"/>
           <a:lstStyle/>
           <a:p>
-            <a:pPr indent="0" marL="0">
+            <a:pPr marL="0" indent="0">
               <a:buNone/>
             </a:pPr>
             <a:r>
@@ -7930,6 +7945,13 @@
           </a:solidFill>
           <a:ln/>
         </p:spPr>
+        <p:txBody>
+          <a:bodyPr/>
+          <a:lstStyle/>
+          <a:p>
+            <a:endParaRPr lang="en-IN"/>
+          </a:p>
+        </p:txBody>
       </p:sp>
       <p:sp>
         <p:nvSpPr>
@@ -7952,7 +7974,7 @@
           <a:bodyPr wrap="square" lIns="0" tIns="0" rIns="0" bIns="0" rtlCol="0" anchor="t"/>
           <a:lstStyle/>
           <a:p>
-            <a:pPr indent="0" marL="0">
+            <a:pPr marL="0" indent="0">
               <a:buNone/>
             </a:pPr>
             <a:r>
@@ -7988,7 +8010,7 @@
           <a:bodyPr wrap="square" lIns="0" tIns="0" rIns="0" bIns="0" rtlCol="0" anchor="t"/>
           <a:lstStyle/>
           <a:p>
-            <a:pPr indent="0" marL="0">
+            <a:pPr marL="0" indent="0">
               <a:buNone/>
             </a:pPr>
             <a:r>
@@ -8024,6 +8046,13 @@
           </a:solidFill>
           <a:ln/>
         </p:spPr>
+        <p:txBody>
+          <a:bodyPr/>
+          <a:lstStyle/>
+          <a:p>
+            <a:endParaRPr lang="en-IN"/>
+          </a:p>
+        </p:txBody>
       </p:sp>
       <p:sp>
         <p:nvSpPr>
@@ -8046,7 +8075,7 @@
           <a:bodyPr wrap="square" lIns="0" tIns="0" rIns="0" bIns="0" rtlCol="0" anchor="t"/>
           <a:lstStyle/>
           <a:p>
-            <a:pPr indent="0" marL="0">
+            <a:pPr marL="0" indent="0">
               <a:buNone/>
             </a:pPr>
             <a:r>
@@ -8082,7 +8111,7 @@
           <a:bodyPr wrap="square" lIns="0" tIns="0" rIns="0" bIns="0" rtlCol="0" anchor="t"/>
           <a:lstStyle/>
           <a:p>
-            <a:pPr indent="0" marL="0">
+            <a:pPr marL="0" indent="0">
               <a:buNone/>
             </a:pPr>
             <a:r>
@@ -8118,7 +8147,7 @@
           <a:bodyPr wrap="square" lIns="0" tIns="0" rIns="0" bIns="0" rtlCol="0" anchor="ctr"/>
           <a:lstStyle/>
           <a:p>
-            <a:pPr indent="0" marL="0">
+            <a:pPr marL="0" indent="0">
               <a:buNone/>
             </a:pPr>
             <a:r>
@@ -8154,6 +8183,13 @@
           </a:solidFill>
           <a:ln/>
         </p:spPr>
+        <p:txBody>
+          <a:bodyPr/>
+          <a:lstStyle/>
+          <a:p>
+            <a:endParaRPr lang="en-IN"/>
+          </a:p>
+        </p:txBody>
       </p:sp>
       <p:sp>
         <p:nvSpPr>
@@ -8176,7 +8212,7 @@
           <a:bodyPr wrap="square" lIns="0" tIns="0" rIns="0" bIns="0" rtlCol="0" anchor="ctr"/>
           <a:lstStyle/>
           <a:p>
-            <a:pPr algn="ctr" indent="0" marL="0">
+            <a:pPr marL="0" indent="0" algn="ctr">
               <a:buNone/>
             </a:pPr>
             <a:r>
@@ -8215,6 +8251,13 @@
           </a:solidFill>
           <a:ln/>
         </p:spPr>
+        <p:txBody>
+          <a:bodyPr/>
+          <a:lstStyle/>
+          <a:p>
+            <a:endParaRPr lang="en-IN"/>
+          </a:p>
+        </p:txBody>
       </p:sp>
       <p:sp>
         <p:nvSpPr>
@@ -8237,7 +8280,7 @@
           <a:bodyPr wrap="square" lIns="0" tIns="0" rIns="0" bIns="0" rtlCol="0" anchor="ctr"/>
           <a:lstStyle/>
           <a:p>
-            <a:pPr algn="ctr" indent="0" marL="0">
+            <a:pPr marL="0" indent="0" algn="ctr">
               <a:buNone/>
             </a:pPr>
             <a:r>
@@ -8276,6 +8319,13 @@
           </a:solidFill>
           <a:ln/>
         </p:spPr>
+        <p:txBody>
+          <a:bodyPr/>
+          <a:lstStyle/>
+          <a:p>
+            <a:endParaRPr lang="en-IN"/>
+          </a:p>
+        </p:txBody>
       </p:sp>
       <p:sp>
         <p:nvSpPr>
@@ -8298,7 +8348,7 @@
           <a:bodyPr wrap="square" lIns="0" tIns="0" rIns="0" bIns="0" rtlCol="0" anchor="ctr"/>
           <a:lstStyle/>
           <a:p>
-            <a:pPr algn="ctr" indent="0" marL="0">
+            <a:pPr marL="0" indent="0" algn="ctr">
               <a:buNone/>
             </a:pPr>
             <a:r>
@@ -8337,6 +8387,13 @@
           </a:solidFill>
           <a:ln/>
         </p:spPr>
+        <p:txBody>
+          <a:bodyPr/>
+          <a:lstStyle/>
+          <a:p>
+            <a:endParaRPr lang="en-IN"/>
+          </a:p>
+        </p:txBody>
       </p:sp>
       <p:sp>
         <p:nvSpPr>
@@ -8359,7 +8416,7 @@
           <a:bodyPr wrap="square" lIns="0" tIns="0" rIns="0" bIns="0" rtlCol="0" anchor="ctr"/>
           <a:lstStyle/>
           <a:p>
-            <a:pPr algn="ctr" indent="0" marL="0">
+            <a:pPr marL="0" indent="0" algn="ctr">
               <a:buNone/>
             </a:pPr>
             <a:r>
@@ -8398,6 +8455,13 @@
           </a:solidFill>
           <a:ln/>
         </p:spPr>
+        <p:txBody>
+          <a:bodyPr/>
+          <a:lstStyle/>
+          <a:p>
+            <a:endParaRPr lang="en-IN"/>
+          </a:p>
+        </p:txBody>
       </p:sp>
       <p:sp>
         <p:nvSpPr>
@@ -8420,7 +8484,7 @@
           <a:bodyPr wrap="square" lIns="0" tIns="0" rIns="0" bIns="0" rtlCol="0" anchor="ctr"/>
           <a:lstStyle/>
           <a:p>
-            <a:pPr algn="ctr" indent="0" marL="0">
+            <a:pPr marL="0" indent="0" algn="ctr">
               <a:buNone/>
             </a:pPr>
             <a:r>
@@ -8440,7 +8504,7 @@
       </p:sp>
       <p:sp>
         <p:nvSpPr>
-          <p:cNvPr id="25" name="Slide Number Placeholder 0"/>
+          <p:cNvPr id="47" name="Slide Number Placeholder 0"/>
           <p:cNvSpPr>
             <a:spLocks noGrp="1"/>
           </p:cNvSpPr>
@@ -8458,7 +8522,7 @@
           </a:prstGeom>
           <a:extLst>
             <a:ext uri="{C572A759-6A51-4108-AA02-DFA0A04FC94B}">
-              <ma14:wrappingTextBoxFlag xmlns:ma14="http://schemas.microsoft.com/office/mac/drawingml/2011/main" val="0"/>
+              <ma14:wrappingTextBoxFlag xmlns:ma14="http://schemas.microsoft.com/office/mac/drawingml/2011/main" xmlns="" val="0"/>
             </a:ext>
           </a:extLst>
         </p:spPr>
@@ -8476,7 +8540,7 @@
           <a:p>
             <a:pPr algn="r"/>
             <a:fld id="{F7021451-1387-4CA6-816F-3879F97B5CBC}" type="slidenum">
-              <a:rPr b="0" lang="en-US"/>
+              <a:rPr lang="en-US" b="0"/>
               <a:t>3</a:t>
             </a:fld>
             <a:endParaRPr lang="en-US"/>
@@ -8511,9 +8575,11 @@
       <p:sp>
         <p:nvSpPr>
           <p:cNvPr id="2" name="Text 0"/>
-          <p:cNvSpPr/>
+          <p:cNvSpPr>
+            <a:spLocks noGrp="1"/>
+          </p:cNvSpPr>
           <p:nvPr>
-            <p:ph idx="100" type="body" hasCustomPrompt="1"/>
+            <p:ph type="body" idx="100" hasCustomPrompt="1"/>
           </p:nvPr>
         </p:nvSpPr>
         <p:spPr>
@@ -8531,11 +8597,11 @@
           <a:bodyPr wrap="square" lIns="0" tIns="0" rIns="0" bIns="0" rtlCol="0"/>
           <a:lstStyle/>
           <a:p>
-            <a:pPr indent="0" marL="0">
-              <a:buNone/>
-            </a:pPr>
-            <a:r>
-              <a:rPr lang="en-US" sz="1300" spc="200" kern="0" dirty="0">
+            <a:pPr marL="0" indent="0">
+              <a:buNone/>
+            </a:pPr>
+            <a:r>
+              <a:rPr lang="en-US" sz="1300" kern="0" spc="200" dirty="0">
                 <a:solidFill>
                   <a:schemeClr val="accent5"/>
                 </a:solidFill>
@@ -8552,9 +8618,11 @@
       <p:sp>
         <p:nvSpPr>
           <p:cNvPr id="3" name="Text 0"/>
-          <p:cNvSpPr/>
+          <p:cNvSpPr>
+            <a:spLocks noGrp="1"/>
+          </p:cNvSpPr>
           <p:nvPr>
-            <p:ph idx="101" type="title" hasCustomPrompt="1"/>
+            <p:ph type="title" idx="101" hasCustomPrompt="1"/>
           </p:nvPr>
         </p:nvSpPr>
         <p:spPr>
@@ -8572,7 +8640,7 @@
           <a:bodyPr wrap="square" lIns="0" tIns="0" rIns="0" bIns="0" rtlCol="0" anchor="t"/>
           <a:lstStyle/>
           <a:p>
-            <a:pPr algn="l" indent="0" marL="0">
+            <a:pPr marL="0" indent="0" algn="l">
               <a:buNone/>
             </a:pPr>
             <a:r>
@@ -8606,6 +8674,13 @@
           </a:solidFill>
           <a:ln/>
         </p:spPr>
+        <p:txBody>
+          <a:bodyPr/>
+          <a:lstStyle/>
+          <a:p>
+            <a:endParaRPr lang="en-IN"/>
+          </a:p>
+        </p:txBody>
       </p:sp>
       <p:sp>
         <p:nvSpPr>
@@ -8628,7 +8703,7 @@
           <a:bodyPr wrap="square" lIns="0" tIns="0" rIns="0" bIns="0" rtlCol="0" anchor="t"/>
           <a:lstStyle/>
           <a:p>
-            <a:pPr indent="0" marL="0">
+            <a:pPr marL="0" indent="0">
               <a:buNone/>
             </a:pPr>
             <a:r>
@@ -8664,7 +8739,7 @@
           <a:bodyPr wrap="square" lIns="0" tIns="0" rIns="0" bIns="0" rtlCol="0" anchor="t"/>
           <a:lstStyle/>
           <a:p>
-            <a:pPr indent="0" marL="0">
+            <a:pPr marL="0" indent="0">
               <a:buNone/>
             </a:pPr>
             <a:r>
@@ -8698,6 +8773,13 @@
           </a:solidFill>
           <a:ln/>
         </p:spPr>
+        <p:txBody>
+          <a:bodyPr/>
+          <a:lstStyle/>
+          <a:p>
+            <a:endParaRPr lang="en-IN"/>
+          </a:p>
+        </p:txBody>
       </p:sp>
       <p:sp>
         <p:nvSpPr>
@@ -8720,7 +8802,7 @@
           <a:bodyPr wrap="square" lIns="0" tIns="0" rIns="0" bIns="0" rtlCol="0" anchor="t"/>
           <a:lstStyle/>
           <a:p>
-            <a:pPr indent="0" marL="0">
+            <a:pPr marL="0" indent="0">
               <a:buNone/>
             </a:pPr>
             <a:r>
@@ -8756,7 +8838,7 @@
           <a:bodyPr wrap="square" lIns="0" tIns="0" rIns="0" bIns="0" rtlCol="0" anchor="t"/>
           <a:lstStyle/>
           <a:p>
-            <a:pPr indent="0" marL="0">
+            <a:pPr marL="0" indent="0">
               <a:buNone/>
             </a:pPr>
             <a:r>
@@ -8790,6 +8872,13 @@
           </a:solidFill>
           <a:ln/>
         </p:spPr>
+        <p:txBody>
+          <a:bodyPr/>
+          <a:lstStyle/>
+          <a:p>
+            <a:endParaRPr lang="en-IN"/>
+          </a:p>
+        </p:txBody>
       </p:sp>
       <p:sp>
         <p:nvSpPr>
@@ -8812,7 +8901,7 @@
           <a:bodyPr wrap="square" lIns="0" tIns="0" rIns="0" bIns="0" rtlCol="0" anchor="t"/>
           <a:lstStyle/>
           <a:p>
-            <a:pPr indent="0" marL="0">
+            <a:pPr marL="0" indent="0">
               <a:buNone/>
             </a:pPr>
             <a:r>
@@ -8848,7 +8937,7 @@
           <a:bodyPr wrap="square" lIns="0" tIns="0" rIns="0" bIns="0" rtlCol="0" anchor="t"/>
           <a:lstStyle/>
           <a:p>
-            <a:pPr indent="0" marL="0">
+            <a:pPr marL="0" indent="0">
               <a:buNone/>
             </a:pPr>
             <a:r>
@@ -8882,6 +8971,13 @@
           </a:solidFill>
           <a:ln/>
         </p:spPr>
+        <p:txBody>
+          <a:bodyPr/>
+          <a:lstStyle/>
+          <a:p>
+            <a:endParaRPr lang="en-IN"/>
+          </a:p>
+        </p:txBody>
       </p:sp>
       <p:sp>
         <p:nvSpPr>
@@ -8904,7 +9000,7 @@
           <a:bodyPr wrap="square" lIns="0" tIns="0" rIns="0" bIns="0" rtlCol="0" anchor="t"/>
           <a:lstStyle/>
           <a:p>
-            <a:pPr indent="0" marL="0">
+            <a:pPr marL="0" indent="0">
               <a:buNone/>
             </a:pPr>
             <a:r>
@@ -8940,7 +9036,7 @@
           <a:bodyPr wrap="square" lIns="0" tIns="0" rIns="0" bIns="0" rtlCol="0" anchor="t"/>
           <a:lstStyle/>
           <a:p>
-            <a:pPr indent="0" marL="0">
+            <a:pPr marL="0" indent="0">
               <a:buNone/>
             </a:pPr>
             <a:r>
@@ -8976,7 +9072,7 @@
           <a:bodyPr wrap="square" lIns="0" tIns="0" rIns="0" bIns="0" rtlCol="0" anchor="t"/>
           <a:lstStyle/>
           <a:p>
-            <a:pPr indent="0" marL="0">
+            <a:pPr marL="0" indent="0">
               <a:buNone/>
             </a:pPr>
             <a:r>
@@ -9014,7 +9110,7 @@
           </a:prstGeom>
           <a:extLst>
             <a:ext uri="{C572A759-6A51-4108-AA02-DFA0A04FC94B}">
-              <ma14:wrappingTextBoxFlag xmlns:ma14="http://schemas.microsoft.com/office/mac/drawingml/2011/main" val="0"/>
+              <ma14:wrappingTextBoxFlag xmlns:ma14="http://schemas.microsoft.com/office/mac/drawingml/2011/main" xmlns="" val="0"/>
             </a:ext>
           </a:extLst>
         </p:spPr>
@@ -9032,7 +9128,7 @@
           <a:p>
             <a:pPr algn="r"/>
             <a:fld id="{F7021451-1387-4CA6-816F-3879F97B5CBC}" type="slidenum">
-              <a:rPr b="0" lang="en-US"/>
+              <a:rPr lang="en-US" b="0"/>
               <a:t>4</a:t>
             </a:fld>
             <a:endParaRPr lang="en-US"/>
@@ -9067,9 +9163,11 @@
       <p:sp>
         <p:nvSpPr>
           <p:cNvPr id="2" name="Text 0"/>
-          <p:cNvSpPr/>
+          <p:cNvSpPr>
+            <a:spLocks noGrp="1"/>
+          </p:cNvSpPr>
           <p:nvPr>
-            <p:ph idx="100" type="body" hasCustomPrompt="1"/>
+            <p:ph type="body" idx="100" hasCustomPrompt="1"/>
           </p:nvPr>
         </p:nvSpPr>
         <p:spPr>
@@ -9087,11 +9185,11 @@
           <a:bodyPr wrap="square" lIns="0" tIns="0" rIns="0" bIns="0" rtlCol="0"/>
           <a:lstStyle/>
           <a:p>
-            <a:pPr indent="0" marL="0">
-              <a:buNone/>
-            </a:pPr>
-            <a:r>
-              <a:rPr lang="en-US" sz="1300" spc="200" kern="0" dirty="0">
+            <a:pPr marL="0" indent="0">
+              <a:buNone/>
+            </a:pPr>
+            <a:r>
+              <a:rPr lang="en-US" sz="1300" kern="0" spc="200" dirty="0">
                 <a:solidFill>
                   <a:schemeClr val="accent1"/>
                 </a:solidFill>
@@ -9108,9 +9206,11 @@
       <p:sp>
         <p:nvSpPr>
           <p:cNvPr id="3" name="Text 0"/>
-          <p:cNvSpPr/>
+          <p:cNvSpPr>
+            <a:spLocks noGrp="1"/>
+          </p:cNvSpPr>
           <p:nvPr>
-            <p:ph idx="101" type="title" hasCustomPrompt="1"/>
+            <p:ph type="title" idx="101" hasCustomPrompt="1"/>
           </p:nvPr>
         </p:nvSpPr>
         <p:spPr>
@@ -9128,7 +9228,7 @@
           <a:bodyPr wrap="square" lIns="0" tIns="0" rIns="0" bIns="0" rtlCol="0" anchor="t"/>
           <a:lstStyle/>
           <a:p>
-            <a:pPr algn="l" indent="0" marL="0">
+            <a:pPr marL="0" indent="0" algn="l">
               <a:buNone/>
             </a:pPr>
             <a:r>
@@ -9159,16 +9259,34 @@
         </p:nvGraphicFramePr>
         <p:xfrm>
           <a:off x="548640" y="1783080"/>
-          <a:ext cx="11094415" cy="914400"/>
+          <a:ext cx="11094415" cy="2966720"/>
         </p:xfrm>
         <a:graphic>
           <a:graphicData uri="http://schemas.openxmlformats.org/drawingml/2006/table">
             <a:tbl>
               <a:tblPr/>
               <a:tblGrid>
-                <a:gridCol w="2743200"/>
-                <a:gridCol w="4754880"/>
-                <a:gridCol w="3596335"/>
+                <a:gridCol w="2743200">
+                  <a:extLst>
+                    <a:ext uri="{9D8B030D-6E8A-4147-A177-3AD203B41FA5}">
+                      <a16:colId xmlns:a16="http://schemas.microsoft.com/office/drawing/2014/main" val="20000"/>
+                    </a:ext>
+                  </a:extLst>
+                </a:gridCol>
+                <a:gridCol w="4754880">
+                  <a:extLst>
+                    <a:ext uri="{9D8B030D-6E8A-4147-A177-3AD203B41FA5}">
+                      <a16:colId xmlns:a16="http://schemas.microsoft.com/office/drawing/2014/main" val="20001"/>
+                    </a:ext>
+                  </a:extLst>
+                </a:gridCol>
+                <a:gridCol w="3596335">
+                  <a:extLst>
+                    <a:ext uri="{9D8B030D-6E8A-4147-A177-3AD203B41FA5}">
+                      <a16:colId xmlns:a16="http://schemas.microsoft.com/office/drawing/2014/main" val="20002"/>
+                    </a:ext>
+                  </a:extLst>
+                </a:gridCol>
               </a:tblGrid>
               <a:tr h="0">
                 <a:tc>
@@ -9176,7 +9294,7 @@
                     <a:bodyPr/>
                     <a:lstStyle/>
                     <a:p>
-                      <a:pPr indent="0" marL="0">
+                      <a:pPr marL="0" indent="0">
                         <a:buNone/>
                       </a:pPr>
                       <a:r>
@@ -9237,7 +9355,7 @@
                     <a:bodyPr/>
                     <a:lstStyle/>
                     <a:p>
-                      <a:pPr indent="0" marL="0">
+                      <a:pPr marL="0" indent="0">
                         <a:buNone/>
                       </a:pPr>
                       <a:r>
@@ -9298,7 +9416,7 @@
                     <a:bodyPr/>
                     <a:lstStyle/>
                     <a:p>
-                      <a:pPr indent="0" marL="0">
+                      <a:pPr marL="0" indent="0">
                         <a:buNone/>
                       </a:pPr>
                       <a:r>
@@ -9354,6 +9472,11 @@
                     </a:solidFill>
                   </a:tcPr>
                 </a:tc>
+                <a:extLst>
+                  <a:ext uri="{0D108BD9-81ED-4DB2-BD59-A6C34878D82A}">
+                    <a16:rowId xmlns:a16="http://schemas.microsoft.com/office/drawing/2014/main" val="10000"/>
+                  </a:ext>
+                </a:extLst>
               </a:tr>
               <a:tr h="0">
                 <a:tc>
@@ -9361,7 +9484,7 @@
                     <a:bodyPr/>
                     <a:lstStyle/>
                     <a:p>
-                      <a:pPr indent="0" marL="0">
+                      <a:pPr marL="0" indent="0">
                         <a:buNone/>
                       </a:pPr>
                       <a:r>
@@ -9422,7 +9545,7 @@
                     <a:bodyPr/>
                     <a:lstStyle/>
                     <a:p>
-                      <a:pPr indent="0" marL="0">
+                      <a:pPr marL="0" indent="0">
                         <a:buNone/>
                       </a:pPr>
                       <a:r>
@@ -9483,7 +9606,7 @@
                     <a:bodyPr/>
                     <a:lstStyle/>
                     <a:p>
-                      <a:pPr indent="0" marL="0">
+                      <a:pPr marL="0" indent="0">
                         <a:buNone/>
                       </a:pPr>
                       <a:r>
@@ -9539,6 +9662,11 @@
                     </a:solidFill>
                   </a:tcPr>
                 </a:tc>
+                <a:extLst>
+                  <a:ext uri="{0D108BD9-81ED-4DB2-BD59-A6C34878D82A}">
+                    <a16:rowId xmlns:a16="http://schemas.microsoft.com/office/drawing/2014/main" val="10001"/>
+                  </a:ext>
+                </a:extLst>
               </a:tr>
               <a:tr h="0">
                 <a:tc>
@@ -9546,7 +9674,7 @@
                     <a:bodyPr/>
                     <a:lstStyle/>
                     <a:p>
-                      <a:pPr indent="0" marL="0">
+                      <a:pPr marL="0" indent="0">
                         <a:buNone/>
                       </a:pPr>
                       <a:r>
@@ -9607,7 +9735,7 @@
                     <a:bodyPr/>
                     <a:lstStyle/>
                     <a:p>
-                      <a:pPr indent="0" marL="0">
+                      <a:pPr marL="0" indent="0">
                         <a:buNone/>
                       </a:pPr>
                       <a:r>
@@ -9668,7 +9796,7 @@
                     <a:bodyPr/>
                     <a:lstStyle/>
                     <a:p>
-                      <a:pPr indent="0" marL="0">
+                      <a:pPr marL="0" indent="0">
                         <a:buNone/>
                       </a:pPr>
                       <a:r>
@@ -9724,6 +9852,11 @@
                     </a:solidFill>
                   </a:tcPr>
                 </a:tc>
+                <a:extLst>
+                  <a:ext uri="{0D108BD9-81ED-4DB2-BD59-A6C34878D82A}">
+                    <a16:rowId xmlns:a16="http://schemas.microsoft.com/office/drawing/2014/main" val="10002"/>
+                  </a:ext>
+                </a:extLst>
               </a:tr>
               <a:tr h="0">
                 <a:tc>
@@ -9731,7 +9864,7 @@
                     <a:bodyPr/>
                     <a:lstStyle/>
                     <a:p>
-                      <a:pPr indent="0" marL="0">
+                      <a:pPr marL="0" indent="0">
                         <a:buNone/>
                       </a:pPr>
                       <a:r>
@@ -9792,7 +9925,7 @@
                     <a:bodyPr/>
                     <a:lstStyle/>
                     <a:p>
-                      <a:pPr indent="0" marL="0">
+                      <a:pPr marL="0" indent="0">
                         <a:buNone/>
                       </a:pPr>
                       <a:r>
@@ -9853,7 +9986,7 @@
                     <a:bodyPr/>
                     <a:lstStyle/>
                     <a:p>
-                      <a:pPr indent="0" marL="0">
+                      <a:pPr marL="0" indent="0">
                         <a:buNone/>
                       </a:pPr>
                       <a:r>
@@ -9909,6 +10042,11 @@
                     </a:solidFill>
                   </a:tcPr>
                 </a:tc>
+                <a:extLst>
+                  <a:ext uri="{0D108BD9-81ED-4DB2-BD59-A6C34878D82A}">
+                    <a16:rowId xmlns:a16="http://schemas.microsoft.com/office/drawing/2014/main" val="10003"/>
+                  </a:ext>
+                </a:extLst>
               </a:tr>
               <a:tr h="0">
                 <a:tc>
@@ -9916,7 +10054,7 @@
                     <a:bodyPr/>
                     <a:lstStyle/>
                     <a:p>
-                      <a:pPr indent="0" marL="0">
+                      <a:pPr marL="0" indent="0">
                         <a:buNone/>
                       </a:pPr>
                       <a:r>
@@ -9977,7 +10115,7 @@
                     <a:bodyPr/>
                     <a:lstStyle/>
                     <a:p>
-                      <a:pPr indent="0" marL="0">
+                      <a:pPr marL="0" indent="0">
                         <a:buNone/>
                       </a:pPr>
                       <a:r>
@@ -10038,7 +10176,7 @@
                     <a:bodyPr/>
                     <a:lstStyle/>
                     <a:p>
-                      <a:pPr indent="0" marL="0">
+                      <a:pPr marL="0" indent="0">
                         <a:buNone/>
                       </a:pPr>
                       <a:r>
@@ -10094,6 +10232,11 @@
                     </a:solidFill>
                   </a:tcPr>
                 </a:tc>
+                <a:extLst>
+                  <a:ext uri="{0D108BD9-81ED-4DB2-BD59-A6C34878D82A}">
+                    <a16:rowId xmlns:a16="http://schemas.microsoft.com/office/drawing/2014/main" val="10004"/>
+                  </a:ext>
+                </a:extLst>
               </a:tr>
               <a:tr h="0">
                 <a:tc>
@@ -10101,7 +10244,7 @@
                     <a:bodyPr/>
                     <a:lstStyle/>
                     <a:p>
-                      <a:pPr indent="0" marL="0">
+                      <a:pPr marL="0" indent="0">
                         <a:buNone/>
                       </a:pPr>
                       <a:r>
@@ -10162,7 +10305,7 @@
                     <a:bodyPr/>
                     <a:lstStyle/>
                     <a:p>
-                      <a:pPr indent="0" marL="0">
+                      <a:pPr marL="0" indent="0">
                         <a:buNone/>
                       </a:pPr>
                       <a:r>
@@ -10223,7 +10366,7 @@
                     <a:bodyPr/>
                     <a:lstStyle/>
                     <a:p>
-                      <a:pPr indent="0" marL="0">
+                      <a:pPr marL="0" indent="0">
                         <a:buNone/>
                       </a:pPr>
                       <a:r>
@@ -10279,6 +10422,11 @@
                     </a:solidFill>
                   </a:tcPr>
                 </a:tc>
+                <a:extLst>
+                  <a:ext uri="{0D108BD9-81ED-4DB2-BD59-A6C34878D82A}">
+                    <a16:rowId xmlns:a16="http://schemas.microsoft.com/office/drawing/2014/main" val="10005"/>
+                  </a:ext>
+                </a:extLst>
               </a:tr>
               <a:tr h="0">
                 <a:tc>
@@ -10286,7 +10434,7 @@
                     <a:bodyPr/>
                     <a:lstStyle/>
                     <a:p>
-                      <a:pPr indent="0" marL="0">
+                      <a:pPr marL="0" indent="0">
                         <a:buNone/>
                       </a:pPr>
                       <a:r>
@@ -10347,7 +10495,7 @@
                     <a:bodyPr/>
                     <a:lstStyle/>
                     <a:p>
-                      <a:pPr indent="0" marL="0">
+                      <a:pPr marL="0" indent="0">
                         <a:buNone/>
                       </a:pPr>
                       <a:r>
@@ -10408,7 +10556,7 @@
                     <a:bodyPr/>
                     <a:lstStyle/>
                     <a:p>
-                      <a:pPr indent="0" marL="0">
+                      <a:pPr marL="0" indent="0">
                         <a:buNone/>
                       </a:pPr>
                       <a:r>
@@ -10464,6 +10612,11 @@
                     </a:solidFill>
                   </a:tcPr>
                 </a:tc>
+                <a:extLst>
+                  <a:ext uri="{0D108BD9-81ED-4DB2-BD59-A6C34878D82A}">
+                    <a16:rowId xmlns:a16="http://schemas.microsoft.com/office/drawing/2014/main" val="10006"/>
+                  </a:ext>
+                </a:extLst>
               </a:tr>
               <a:tr h="0">
                 <a:tc>
@@ -10471,7 +10624,7 @@
                     <a:bodyPr/>
                     <a:lstStyle/>
                     <a:p>
-                      <a:pPr indent="0" marL="0">
+                      <a:pPr marL="0" indent="0">
                         <a:buNone/>
                       </a:pPr>
                       <a:r>
@@ -10532,7 +10685,7 @@
                     <a:bodyPr/>
                     <a:lstStyle/>
                     <a:p>
-                      <a:pPr indent="0" marL="0">
+                      <a:pPr marL="0" indent="0">
                         <a:buNone/>
                       </a:pPr>
                       <a:r>
@@ -10593,7 +10746,7 @@
                     <a:bodyPr/>
                     <a:lstStyle/>
                     <a:p>
-                      <a:pPr indent="0" marL="0">
+                      <a:pPr marL="0" indent="0">
                         <a:buNone/>
                       </a:pPr>
                       <a:r>
@@ -10649,6 +10802,11 @@
                     </a:solidFill>
                   </a:tcPr>
                 </a:tc>
+                <a:extLst>
+                  <a:ext uri="{0D108BD9-81ED-4DB2-BD59-A6C34878D82A}">
+                    <a16:rowId xmlns:a16="http://schemas.microsoft.com/office/drawing/2014/main" val="10007"/>
+                  </a:ext>
+                </a:extLst>
               </a:tr>
             </a:tbl>
           </a:graphicData>
@@ -10674,7 +10832,7 @@
           </a:prstGeom>
           <a:extLst>
             <a:ext uri="{C572A759-6A51-4108-AA02-DFA0A04FC94B}">
-              <ma14:wrappingTextBoxFlag xmlns:ma14="http://schemas.microsoft.com/office/mac/drawingml/2011/main" val="0"/>
+              <ma14:wrappingTextBoxFlag xmlns:ma14="http://schemas.microsoft.com/office/mac/drawingml/2011/main" xmlns="" val="0"/>
             </a:ext>
           </a:extLst>
         </p:spPr>
@@ -10692,7 +10850,7 @@
           <a:p>
             <a:pPr algn="r"/>
             <a:fld id="{F7021451-1387-4CA6-816F-3879F97B5CBC}" type="slidenum">
-              <a:rPr b="0" lang="en-US"/>
+              <a:rPr lang="en-US" b="0"/>
               <a:t>5</a:t>
             </a:fld>
             <a:endParaRPr lang="en-US"/>
@@ -10727,9 +10885,11 @@
       <p:sp>
         <p:nvSpPr>
           <p:cNvPr id="2" name="Text 0"/>
-          <p:cNvSpPr/>
+          <p:cNvSpPr>
+            <a:spLocks noGrp="1"/>
+          </p:cNvSpPr>
           <p:nvPr>
-            <p:ph idx="100" type="body" hasCustomPrompt="1"/>
+            <p:ph type="body" idx="100" hasCustomPrompt="1"/>
           </p:nvPr>
         </p:nvSpPr>
         <p:spPr>
@@ -10747,11 +10907,11 @@
           <a:bodyPr wrap="square" lIns="0" tIns="0" rIns="0" bIns="0" rtlCol="0"/>
           <a:lstStyle/>
           <a:p>
-            <a:pPr indent="0" marL="0">
-              <a:buNone/>
-            </a:pPr>
-            <a:r>
-              <a:rPr lang="en-US" sz="1300" spc="200" kern="0" dirty="0">
+            <a:pPr marL="0" indent="0">
+              <a:buNone/>
+            </a:pPr>
+            <a:r>
+              <a:rPr lang="en-US" sz="1300" kern="0" spc="200" dirty="0">
                 <a:solidFill>
                   <a:schemeClr val="accent1"/>
                 </a:solidFill>
@@ -10768,9 +10928,11 @@
       <p:sp>
         <p:nvSpPr>
           <p:cNvPr id="3" name="Text 0"/>
-          <p:cNvSpPr/>
+          <p:cNvSpPr>
+            <a:spLocks noGrp="1"/>
+          </p:cNvSpPr>
           <p:nvPr>
-            <p:ph idx="101" type="title" hasCustomPrompt="1"/>
+            <p:ph type="title" idx="101" hasCustomPrompt="1"/>
           </p:nvPr>
         </p:nvSpPr>
         <p:spPr>
@@ -10788,7 +10950,7 @@
           <a:bodyPr wrap="square" lIns="0" tIns="0" rIns="0" bIns="0" rtlCol="0" anchor="t"/>
           <a:lstStyle/>
           <a:p>
-            <a:pPr algn="l" indent="0" marL="0">
+            <a:pPr marL="0" indent="0" algn="l">
               <a:buNone/>
             </a:pPr>
             <a:r>
@@ -10829,6 +10991,13 @@
             <a:prstDash val="solid"/>
           </a:ln>
         </p:spPr>
+        <p:txBody>
+          <a:bodyPr/>
+          <a:lstStyle/>
+          <a:p>
+            <a:endParaRPr lang="en-IN"/>
+          </a:p>
+        </p:txBody>
       </p:sp>
       <p:sp>
         <p:nvSpPr>
@@ -10851,7 +11020,7 @@
           <a:bodyPr wrap="square" lIns="0" tIns="0" rIns="0" bIns="0" rtlCol="0" anchor="t"/>
           <a:lstStyle/>
           <a:p>
-            <a:pPr indent="0" marL="0">
+            <a:pPr marL="0" indent="0">
               <a:buNone/>
             </a:pPr>
             <a:r>
@@ -10890,7 +11059,7 @@
           <a:bodyPr wrap="square" lIns="0" tIns="0" rIns="0" bIns="0" rtlCol="0" anchor="t"/>
           <a:lstStyle/>
           <a:p>
-            <a:pPr indent="0" marL="0">
+            <a:pPr marL="0" indent="0">
               <a:buNone/>
             </a:pPr>
             <a:r>
@@ -11043,6 +11212,13 @@
             <a:prstDash val="solid"/>
           </a:ln>
         </p:spPr>
+        <p:txBody>
+          <a:bodyPr/>
+          <a:lstStyle/>
+          <a:p>
+            <a:endParaRPr lang="en-IN"/>
+          </a:p>
+        </p:txBody>
       </p:sp>
       <p:sp>
         <p:nvSpPr>
@@ -11065,7 +11241,7 @@
           <a:bodyPr wrap="square" lIns="0" tIns="0" rIns="0" bIns="0" rtlCol="0" anchor="t"/>
           <a:lstStyle/>
           <a:p>
-            <a:pPr indent="0" marL="0">
+            <a:pPr marL="0" indent="0">
               <a:buNone/>
             </a:pPr>
             <a:r>
@@ -11104,7 +11280,7 @@
           <a:bodyPr wrap="square" lIns="0" tIns="0" rIns="0" bIns="0" rtlCol="0" anchor="t"/>
           <a:lstStyle/>
           <a:p>
-            <a:pPr indent="0" marL="0">
+            <a:pPr marL="0" indent="0">
               <a:buNone/>
             </a:pPr>
             <a:r>
@@ -11239,6 +11415,13 @@
             <a:prstDash val="solid"/>
           </a:ln>
         </p:spPr>
+        <p:txBody>
+          <a:bodyPr/>
+          <a:lstStyle/>
+          <a:p>
+            <a:endParaRPr lang="en-IN"/>
+          </a:p>
+        </p:txBody>
       </p:sp>
       <p:sp>
         <p:nvSpPr>
@@ -11261,7 +11444,7 @@
           <a:bodyPr wrap="square" lIns="0" tIns="0" rIns="0" bIns="0" rtlCol="0" anchor="t"/>
           <a:lstStyle/>
           <a:p>
-            <a:pPr indent="0" marL="0">
+            <a:pPr marL="0" indent="0">
               <a:buNone/>
             </a:pPr>
             <a:r>
@@ -11300,7 +11483,7 @@
           <a:bodyPr wrap="square" lIns="0" tIns="0" rIns="0" bIns="0" rtlCol="0" anchor="t"/>
           <a:lstStyle/>
           <a:p>
-            <a:pPr indent="0" marL="0">
+            <a:pPr marL="0" indent="0">
               <a:buNone/>
             </a:pPr>
             <a:r>
@@ -11393,7 +11576,7 @@
           </a:prstGeom>
           <a:extLst>
             <a:ext uri="{C572A759-6A51-4108-AA02-DFA0A04FC94B}">
-              <ma14:wrappingTextBoxFlag xmlns:ma14="http://schemas.microsoft.com/office/mac/drawingml/2011/main" val="0"/>
+              <ma14:wrappingTextBoxFlag xmlns:ma14="http://schemas.microsoft.com/office/mac/drawingml/2011/main" xmlns="" val="0"/>
             </a:ext>
           </a:extLst>
         </p:spPr>
@@ -11411,7 +11594,7 @@
           <a:p>
             <a:pPr algn="r"/>
             <a:fld id="{F7021451-1387-4CA6-816F-3879F97B5CBC}" type="slidenum">
-              <a:rPr b="0" lang="en-US"/>
+              <a:rPr lang="en-US" b="0"/>
               <a:t>6</a:t>
             </a:fld>
             <a:endParaRPr lang="en-US"/>
@@ -11446,9 +11629,11 @@
       <p:sp>
         <p:nvSpPr>
           <p:cNvPr id="2" name="Text 0"/>
-          <p:cNvSpPr/>
+          <p:cNvSpPr>
+            <a:spLocks noGrp="1"/>
+          </p:cNvSpPr>
           <p:nvPr>
-            <p:ph idx="100" type="body" hasCustomPrompt="1"/>
+            <p:ph type="body" idx="100" hasCustomPrompt="1"/>
           </p:nvPr>
         </p:nvSpPr>
         <p:spPr>
@@ -11466,11 +11651,11 @@
           <a:bodyPr wrap="square" lIns="0" tIns="0" rIns="0" bIns="0" rtlCol="0"/>
           <a:lstStyle/>
           <a:p>
-            <a:pPr indent="0" marL="0">
-              <a:buNone/>
-            </a:pPr>
-            <a:r>
-              <a:rPr lang="en-US" sz="1300" spc="200" kern="0" dirty="0">
+            <a:pPr marL="0" indent="0">
+              <a:buNone/>
+            </a:pPr>
+            <a:r>
+              <a:rPr lang="en-US" sz="1300" kern="0" spc="200" dirty="0">
                 <a:solidFill>
                   <a:schemeClr val="accent1"/>
                 </a:solidFill>
@@ -11487,9 +11672,11 @@
       <p:sp>
         <p:nvSpPr>
           <p:cNvPr id="3" name="Text 0"/>
-          <p:cNvSpPr/>
+          <p:cNvSpPr>
+            <a:spLocks noGrp="1"/>
+          </p:cNvSpPr>
           <p:nvPr>
-            <p:ph idx="101" type="title" hasCustomPrompt="1"/>
+            <p:ph type="title" idx="101" hasCustomPrompt="1"/>
           </p:nvPr>
         </p:nvSpPr>
         <p:spPr>
@@ -11507,7 +11694,7 @@
           <a:bodyPr wrap="square" lIns="0" tIns="0" rIns="0" bIns="0" rtlCol="0" anchor="t"/>
           <a:lstStyle/>
           <a:p>
-            <a:pPr algn="l" indent="0" marL="0">
+            <a:pPr marL="0" indent="0" algn="l">
               <a:buNone/>
             </a:pPr>
             <a:r>
@@ -11548,6 +11735,13 @@
             <a:prstDash val="solid"/>
           </a:ln>
         </p:spPr>
+        <p:txBody>
+          <a:bodyPr/>
+          <a:lstStyle/>
+          <a:p>
+            <a:endParaRPr lang="en-IN"/>
+          </a:p>
+        </p:txBody>
       </p:sp>
       <p:sp>
         <p:nvSpPr>
@@ -11570,7 +11764,7 @@
           <a:bodyPr wrap="square" lIns="0" tIns="0" rIns="0" bIns="0" rtlCol="0" anchor="t"/>
           <a:lstStyle/>
           <a:p>
-            <a:pPr indent="0" marL="0">
+            <a:pPr marL="0" indent="0">
               <a:buNone/>
             </a:pPr>
             <a:r>
@@ -11609,7 +11803,7 @@
           <a:bodyPr wrap="square" lIns="0" tIns="0" rIns="0" bIns="0" rtlCol="0" anchor="t"/>
           <a:lstStyle/>
           <a:p>
-            <a:pPr indent="0" marL="0">
+            <a:pPr marL="0" indent="0">
               <a:buNone/>
             </a:pPr>
             <a:r>
@@ -11645,7 +11839,7 @@
           <a:bodyPr wrap="square" lIns="0" tIns="0" rIns="0" bIns="0" rtlCol="0" anchor="t"/>
           <a:lstStyle/>
           <a:p>
-            <a:pPr indent="0" marL="0">
+            <a:pPr marL="0" indent="0">
               <a:buNone/>
             </a:pPr>
             <a:r>
@@ -11683,6 +11877,13 @@
             <a:tailEnd type="triangle"/>
           </a:ln>
         </p:spPr>
+        <p:txBody>
+          <a:bodyPr/>
+          <a:lstStyle/>
+          <a:p>
+            <a:endParaRPr lang="en-IN"/>
+          </a:p>
+        </p:txBody>
       </p:sp>
       <p:sp>
         <p:nvSpPr>
@@ -11710,6 +11911,13 @@
             <a:prstDash val="solid"/>
           </a:ln>
         </p:spPr>
+        <p:txBody>
+          <a:bodyPr/>
+          <a:lstStyle/>
+          <a:p>
+            <a:endParaRPr lang="en-IN"/>
+          </a:p>
+        </p:txBody>
       </p:sp>
       <p:sp>
         <p:nvSpPr>
@@ -11732,7 +11940,7 @@
           <a:bodyPr wrap="square" lIns="0" tIns="0" rIns="0" bIns="0" rtlCol="0" anchor="t"/>
           <a:lstStyle/>
           <a:p>
-            <a:pPr indent="0" marL="0">
+            <a:pPr marL="0" indent="0">
               <a:buNone/>
             </a:pPr>
             <a:r>
@@ -11771,7 +11979,7 @@
           <a:bodyPr wrap="square" lIns="0" tIns="0" rIns="0" bIns="0" rtlCol="0" anchor="t"/>
           <a:lstStyle/>
           <a:p>
-            <a:pPr indent="0" marL="0">
+            <a:pPr marL="0" indent="0">
               <a:buNone/>
             </a:pPr>
             <a:r>
@@ -11807,7 +12015,7 @@
           <a:bodyPr wrap="square" lIns="0" tIns="0" rIns="0" bIns="0" rtlCol="0" anchor="t"/>
           <a:lstStyle/>
           <a:p>
-            <a:pPr indent="0" marL="0">
+            <a:pPr marL="0" indent="0">
               <a:buNone/>
             </a:pPr>
             <a:r>
@@ -11845,6 +12053,13 @@
             <a:tailEnd type="triangle"/>
           </a:ln>
         </p:spPr>
+        <p:txBody>
+          <a:bodyPr/>
+          <a:lstStyle/>
+          <a:p>
+            <a:endParaRPr lang="en-IN"/>
+          </a:p>
+        </p:txBody>
       </p:sp>
       <p:sp>
         <p:nvSpPr>
@@ -11867,6 +12082,13 @@
           </a:solidFill>
           <a:ln/>
         </p:spPr>
+        <p:txBody>
+          <a:bodyPr/>
+          <a:lstStyle/>
+          <a:p>
+            <a:endParaRPr lang="en-IN"/>
+          </a:p>
+        </p:txBody>
       </p:sp>
       <p:sp>
         <p:nvSpPr>
@@ -11889,7 +12111,7 @@
           <a:bodyPr wrap="square" lIns="0" tIns="0" rIns="0" bIns="0" rtlCol="0" anchor="t"/>
           <a:lstStyle/>
           <a:p>
-            <a:pPr indent="0" marL="0">
+            <a:pPr marL="0" indent="0">
               <a:buNone/>
             </a:pPr>
             <a:r>
@@ -11928,7 +12150,7 @@
           <a:bodyPr wrap="square" lIns="0" tIns="0" rIns="0" bIns="0" rtlCol="0" anchor="t"/>
           <a:lstStyle/>
           <a:p>
-            <a:pPr indent="0" marL="0">
+            <a:pPr marL="0" indent="0">
               <a:buNone/>
             </a:pPr>
             <a:r>
@@ -11964,7 +12186,7 @@
           <a:bodyPr wrap="square" lIns="0" tIns="0" rIns="0" bIns="0" rtlCol="0" anchor="t"/>
           <a:lstStyle/>
           <a:p>
-            <a:pPr indent="0" marL="0">
+            <a:pPr marL="0" indent="0">
               <a:buNone/>
             </a:pPr>
             <a:r>
@@ -12000,7 +12222,7 @@
           <a:bodyPr wrap="square" lIns="0" tIns="0" rIns="0" bIns="0" rtlCol="0" anchor="t"/>
           <a:lstStyle/>
           <a:p>
-            <a:pPr indent="0" marL="0">
+            <a:pPr marL="0" indent="0">
               <a:buNone/>
             </a:pPr>
             <a:r>
@@ -12011,9 +12233,6 @@
               </a:rPr>
               <a:t>Runs on: </a:t>
             </a:r>
-            <a:pPr indent="0" marL="0">
-              <a:buNone/>
-            </a:pPr>
             <a:r>
               <a:rPr lang="en-US" sz="1600" dirty="0">
                 <a:solidFill>
@@ -12022,9 +12241,6 @@
               </a:rPr>
               <a:t>GitHub’s free runners, every push and PR     </a:t>
             </a:r>
-            <a:pPr indent="0" marL="0">
-              <a:buNone/>
-            </a:pPr>
             <a:r>
               <a:rPr lang="en-US" sz="1600" b="1" dirty="0">
                 <a:solidFill>
@@ -12033,9 +12249,6 @@
               </a:rPr>
               <a:t>Fails on: </a:t>
             </a:r>
-            <a:pPr indent="0" marL="0">
-              <a:buNone/>
-            </a:pPr>
             <a:r>
               <a:rPr lang="en-US" sz="1600" dirty="0">
                 <a:solidFill>
@@ -12068,7 +12281,7 @@
           </a:prstGeom>
           <a:extLst>
             <a:ext uri="{C572A759-6A51-4108-AA02-DFA0A04FC94B}">
-              <ma14:wrappingTextBoxFlag xmlns:ma14="http://schemas.microsoft.com/office/mac/drawingml/2011/main" val="0"/>
+              <ma14:wrappingTextBoxFlag xmlns:ma14="http://schemas.microsoft.com/office/mac/drawingml/2011/main" xmlns="" val="0"/>
             </a:ext>
           </a:extLst>
         </p:spPr>
@@ -12086,7 +12299,7 @@
           <a:p>
             <a:pPr algn="r"/>
             <a:fld id="{F7021451-1387-4CA6-816F-3879F97B5CBC}" type="slidenum">
-              <a:rPr b="0" lang="en-US"/>
+              <a:rPr lang="en-US" b="0"/>
               <a:t>7</a:t>
             </a:fld>
             <a:endParaRPr lang="en-US"/>
@@ -12121,9 +12334,11 @@
       <p:sp>
         <p:nvSpPr>
           <p:cNvPr id="2" name="Text 0"/>
-          <p:cNvSpPr/>
+          <p:cNvSpPr>
+            <a:spLocks noGrp="1"/>
+          </p:cNvSpPr>
           <p:nvPr>
-            <p:ph idx="100" type="body" hasCustomPrompt="1"/>
+            <p:ph type="body" idx="100" hasCustomPrompt="1"/>
           </p:nvPr>
         </p:nvSpPr>
         <p:spPr>
@@ -12141,11 +12356,11 @@
           <a:bodyPr wrap="square" lIns="0" tIns="0" rIns="0" bIns="0" rtlCol="0"/>
           <a:lstStyle/>
           <a:p>
-            <a:pPr indent="0" marL="0">
-              <a:buNone/>
-            </a:pPr>
-            <a:r>
-              <a:rPr lang="en-US" sz="1300" spc="200" kern="0" dirty="0">
+            <a:pPr marL="0" indent="0">
+              <a:buNone/>
+            </a:pPr>
+            <a:r>
+              <a:rPr lang="en-US" sz="1300" kern="0" spc="200" dirty="0">
                 <a:solidFill>
                   <a:schemeClr val="accent1"/>
                 </a:solidFill>
@@ -12162,9 +12377,11 @@
       <p:sp>
         <p:nvSpPr>
           <p:cNvPr id="3" name="Text 0"/>
-          <p:cNvSpPr/>
+          <p:cNvSpPr>
+            <a:spLocks noGrp="1"/>
+          </p:cNvSpPr>
           <p:nvPr>
-            <p:ph idx="101" type="title" hasCustomPrompt="1"/>
+            <p:ph type="title" idx="101" hasCustomPrompt="1"/>
           </p:nvPr>
         </p:nvSpPr>
         <p:spPr>
@@ -12182,7 +12399,7 @@
           <a:bodyPr wrap="square" lIns="0" tIns="0" rIns="0" bIns="0" rtlCol="0" anchor="t"/>
           <a:lstStyle/>
           <a:p>
-            <a:pPr algn="l" indent="0" marL="0">
+            <a:pPr marL="0" indent="0" algn="l">
               <a:buNone/>
             </a:pPr>
             <a:r>
@@ -12223,6 +12440,13 @@
             <a:prstDash val="solid"/>
           </a:ln>
         </p:spPr>
+        <p:txBody>
+          <a:bodyPr/>
+          <a:lstStyle/>
+          <a:p>
+            <a:endParaRPr lang="en-IN"/>
+          </a:p>
+        </p:txBody>
       </p:sp>
       <p:sp>
         <p:nvSpPr>
@@ -12245,7 +12469,7 @@
           <a:bodyPr wrap="square" lIns="0" tIns="0" rIns="0" bIns="0" rtlCol="0" anchor="t"/>
           <a:lstStyle/>
           <a:p>
-            <a:pPr indent="0" marL="0">
+            <a:pPr marL="0" indent="0">
               <a:buNone/>
             </a:pPr>
             <a:r>
@@ -12281,7 +12505,7 @@
           <a:bodyPr wrap="square" lIns="0" tIns="0" rIns="0" bIns="0" rtlCol="0" anchor="t"/>
           <a:lstStyle/>
           <a:p>
-            <a:pPr indent="0" marL="0">
+            <a:pPr marL="0" indent="0">
               <a:buNone/>
             </a:pPr>
             <a:r>
@@ -12317,7 +12541,7 @@
           <a:bodyPr wrap="square" lIns="0" tIns="0" rIns="0" bIns="0" rtlCol="0" anchor="t"/>
           <a:lstStyle/>
           <a:p>
-            <a:pPr indent="0" marL="0">
+            <a:pPr marL="0" indent="0">
               <a:buNone/>
             </a:pPr>
             <a:r>
@@ -12358,6 +12582,13 @@
             <a:prstDash val="solid"/>
           </a:ln>
         </p:spPr>
+        <p:txBody>
+          <a:bodyPr/>
+          <a:lstStyle/>
+          <a:p>
+            <a:endParaRPr lang="en-IN"/>
+          </a:p>
+        </p:txBody>
       </p:sp>
       <p:sp>
         <p:nvSpPr>
@@ -12380,7 +12611,7 @@
           <a:bodyPr wrap="square" lIns="0" tIns="0" rIns="0" bIns="0" rtlCol="0" anchor="t"/>
           <a:lstStyle/>
           <a:p>
-            <a:pPr indent="0" marL="0">
+            <a:pPr marL="0" indent="0">
               <a:buNone/>
             </a:pPr>
             <a:r>
@@ -12416,7 +12647,7 @@
           <a:bodyPr wrap="square" lIns="0" tIns="0" rIns="0" bIns="0" rtlCol="0" anchor="t"/>
           <a:lstStyle/>
           <a:p>
-            <a:pPr indent="0" marL="0">
+            <a:pPr marL="0" indent="0">
               <a:buNone/>
             </a:pPr>
             <a:r>
@@ -12452,7 +12683,7 @@
           <a:bodyPr wrap="square" lIns="0" tIns="0" rIns="0" bIns="0" rtlCol="0" anchor="t"/>
           <a:lstStyle/>
           <a:p>
-            <a:pPr indent="0" marL="0">
+            <a:pPr marL="0" indent="0">
               <a:buNone/>
             </a:pPr>
             <a:r>
@@ -12493,6 +12724,13 @@
             <a:prstDash val="solid"/>
           </a:ln>
         </p:spPr>
+        <p:txBody>
+          <a:bodyPr/>
+          <a:lstStyle/>
+          <a:p>
+            <a:endParaRPr lang="en-IN"/>
+          </a:p>
+        </p:txBody>
       </p:sp>
       <p:sp>
         <p:nvSpPr>
@@ -12515,7 +12753,7 @@
           <a:bodyPr wrap="square" lIns="0" tIns="0" rIns="0" bIns="0" rtlCol="0" anchor="t"/>
           <a:lstStyle/>
           <a:p>
-            <a:pPr indent="0" marL="0">
+            <a:pPr marL="0" indent="0">
               <a:buNone/>
             </a:pPr>
             <a:r>
@@ -12551,7 +12789,7 @@
           <a:bodyPr wrap="square" lIns="0" tIns="0" rIns="0" bIns="0" rtlCol="0" anchor="t"/>
           <a:lstStyle/>
           <a:p>
-            <a:pPr indent="0" marL="0">
+            <a:pPr marL="0" indent="0">
               <a:buNone/>
             </a:pPr>
             <a:r>
@@ -12587,7 +12825,7 @@
           <a:bodyPr wrap="square" lIns="0" tIns="0" rIns="0" bIns="0" rtlCol="0" anchor="t"/>
           <a:lstStyle/>
           <a:p>
-            <a:pPr indent="0" marL="0">
+            <a:pPr marL="0" indent="0">
               <a:buNone/>
             </a:pPr>
             <a:r>
@@ -12622,7 +12860,7 @@
           </a:prstGeom>
           <a:extLst>
             <a:ext uri="{C572A759-6A51-4108-AA02-DFA0A04FC94B}">
-              <ma14:wrappingTextBoxFlag xmlns:ma14="http://schemas.microsoft.com/office/mac/drawingml/2011/main" val="0"/>
+              <ma14:wrappingTextBoxFlag xmlns:ma14="http://schemas.microsoft.com/office/mac/drawingml/2011/main" xmlns="" val="0"/>
             </a:ext>
           </a:extLst>
         </p:spPr>
@@ -12640,7 +12878,7 @@
           <a:p>
             <a:pPr algn="r"/>
             <a:fld id="{F7021451-1387-4CA6-816F-3879F97B5CBC}" type="slidenum">
-              <a:rPr b="0" lang="en-US"/>
+              <a:rPr lang="en-US" b="0"/>
               <a:t>8</a:t>
             </a:fld>
             <a:endParaRPr lang="en-US"/>
@@ -12675,9 +12913,11 @@
       <p:sp>
         <p:nvSpPr>
           <p:cNvPr id="2" name="Text 0"/>
-          <p:cNvSpPr/>
+          <p:cNvSpPr>
+            <a:spLocks noGrp="1"/>
+          </p:cNvSpPr>
           <p:nvPr>
-            <p:ph idx="100" type="body" hasCustomPrompt="1"/>
+            <p:ph type="body" idx="100" hasCustomPrompt="1"/>
           </p:nvPr>
         </p:nvSpPr>
         <p:spPr>
@@ -12695,11 +12935,11 @@
           <a:bodyPr wrap="square" lIns="0" tIns="0" rIns="0" bIns="0" rtlCol="0"/>
           <a:lstStyle/>
           <a:p>
-            <a:pPr indent="0" marL="0">
-              <a:buNone/>
-            </a:pPr>
-            <a:r>
-              <a:rPr lang="en-US" sz="1300" spc="200" kern="0" dirty="0">
+            <a:pPr marL="0" indent="0">
+              <a:buNone/>
+            </a:pPr>
+            <a:r>
+              <a:rPr lang="en-US" sz="1300" kern="0" spc="200" dirty="0">
                 <a:solidFill>
                   <a:schemeClr val="accent1"/>
                 </a:solidFill>
@@ -12716,9 +12956,11 @@
       <p:sp>
         <p:nvSpPr>
           <p:cNvPr id="3" name="Text 0"/>
-          <p:cNvSpPr/>
+          <p:cNvSpPr>
+            <a:spLocks noGrp="1"/>
+          </p:cNvSpPr>
           <p:nvPr>
-            <p:ph idx="101" type="title" hasCustomPrompt="1"/>
+            <p:ph type="title" idx="101" hasCustomPrompt="1"/>
           </p:nvPr>
         </p:nvSpPr>
         <p:spPr>
@@ -12736,7 +12978,7 @@
           <a:bodyPr wrap="square" lIns="0" tIns="0" rIns="0" bIns="0" rtlCol="0" anchor="t"/>
           <a:lstStyle/>
           <a:p>
-            <a:pPr algn="l" indent="0" marL="0">
+            <a:pPr marL="0" indent="0" algn="l">
               <a:buNone/>
             </a:pPr>
             <a:r>
@@ -12772,7 +13014,7 @@
           <a:bodyPr wrap="square" lIns="0" tIns="0" rIns="0" bIns="0" rtlCol="0" anchor="t"/>
           <a:lstStyle/>
           <a:p>
-            <a:pPr indent="0" marL="0">
+            <a:pPr marL="0" indent="0">
               <a:buNone/>
             </a:pPr>
             <a:r>
@@ -12808,7 +13050,7 @@
           <a:bodyPr wrap="square" lIns="0" tIns="0" rIns="0" bIns="0" rtlCol="0" anchor="t"/>
           <a:lstStyle/>
           <a:p>
-            <a:pPr indent="0" marL="0">
+            <a:pPr marL="0" indent="0">
               <a:buNone/>
             </a:pPr>
             <a:r>
@@ -12844,7 +13086,7 @@
           <a:bodyPr wrap="square" lIns="0" tIns="0" rIns="0" bIns="0" rtlCol="0" anchor="t"/>
           <a:lstStyle/>
           <a:p>
-            <a:pPr indent="0" marL="0">
+            <a:pPr marL="0" indent="0">
               <a:buNone/>
             </a:pPr>
             <a:r>
@@ -12880,7 +13122,7 @@
           <a:bodyPr wrap="square" lIns="0" tIns="0" rIns="0" bIns="0" rtlCol="0" anchor="t"/>
           <a:lstStyle/>
           <a:p>
-            <a:pPr indent="0" marL="0">
+            <a:pPr marL="0" indent="0">
               <a:buNone/>
             </a:pPr>
             <a:r>
@@ -12916,7 +13158,7 @@
           <a:bodyPr wrap="square" lIns="0" tIns="0" rIns="0" bIns="0" rtlCol="0" anchor="t"/>
           <a:lstStyle/>
           <a:p>
-            <a:pPr indent="0" marL="0">
+            <a:pPr marL="0" indent="0">
               <a:buNone/>
             </a:pPr>
             <a:r>
@@ -12952,7 +13194,7 @@
           <a:bodyPr wrap="square" lIns="0" tIns="0" rIns="0" bIns="0" rtlCol="0" anchor="t"/>
           <a:lstStyle/>
           <a:p>
-            <a:pPr indent="0" marL="0">
+            <a:pPr marL="0" indent="0">
               <a:buNone/>
             </a:pPr>
             <a:r>
@@ -12988,7 +13230,7 @@
           <a:bodyPr wrap="square" lIns="0" tIns="0" rIns="0" bIns="0" rtlCol="0" anchor="t"/>
           <a:lstStyle/>
           <a:p>
-            <a:pPr indent="0" marL="0">
+            <a:pPr marL="0" indent="0">
               <a:buNone/>
             </a:pPr>
             <a:r>
@@ -13024,7 +13266,7 @@
           <a:bodyPr wrap="square" lIns="0" tIns="0" rIns="0" bIns="0" rtlCol="0" anchor="t"/>
           <a:lstStyle/>
           <a:p>
-            <a:pPr indent="0" marL="0">
+            <a:pPr marL="0" indent="0">
               <a:buNone/>
             </a:pPr>
             <a:r>
@@ -13060,7 +13302,7 @@
           <a:bodyPr wrap="square" lIns="0" tIns="0" rIns="0" bIns="0" rtlCol="0" anchor="t"/>
           <a:lstStyle/>
           <a:p>
-            <a:pPr indent="0" marL="0">
+            <a:pPr marL="0" indent="0">
               <a:buNone/>
             </a:pPr>
             <a:r>
@@ -13096,6 +13338,13 @@
           </a:solidFill>
           <a:ln/>
         </p:spPr>
+        <p:txBody>
+          <a:bodyPr/>
+          <a:lstStyle/>
+          <a:p>
+            <a:endParaRPr lang="en-IN"/>
+          </a:p>
+        </p:txBody>
       </p:sp>
       <p:sp>
         <p:nvSpPr>
@@ -13118,7 +13367,7 @@
           <a:bodyPr wrap="square" lIns="0" tIns="0" rIns="0" bIns="0" rtlCol="0" anchor="t"/>
           <a:lstStyle/>
           <a:p>
-            <a:pPr indent="0" marL="0">
+            <a:pPr marL="0" indent="0">
               <a:buNone/>
             </a:pPr>
             <a:r>
@@ -13135,7 +13384,7 @@
             <a:endParaRPr lang="en-US" sz="1200" dirty="0"/>
           </a:p>
           <a:p>
-            <a:pPr indent="0" marL="0">
+            <a:pPr marL="0" indent="0">
               <a:buNone/>
             </a:pPr>
             <a:r>
@@ -13152,7 +13401,7 @@
             <a:endParaRPr lang="en-US" sz="1200" dirty="0"/>
           </a:p>
           <a:p>
-            <a:pPr indent="0" marL="0">
+            <a:pPr marL="0" indent="0">
               <a:buNone/>
             </a:pPr>
             <a:r>
@@ -13169,7 +13418,7 @@
             <a:endParaRPr lang="en-US" sz="1200" dirty="0"/>
           </a:p>
           <a:p>
-            <a:pPr indent="0" marL="0">
+            <a:pPr marL="0" indent="0">
               <a:buNone/>
             </a:pPr>
             <a:r>
@@ -13186,7 +13435,7 @@
             <a:endParaRPr lang="en-US" sz="1200" dirty="0"/>
           </a:p>
           <a:p>
-            <a:pPr indent="0" marL="0">
+            <a:pPr marL="0" indent="0">
               <a:buNone/>
             </a:pPr>
             <a:r>
@@ -13203,7 +13452,7 @@
             <a:endParaRPr lang="en-US" sz="1200" dirty="0"/>
           </a:p>
           <a:p>
-            <a:pPr indent="0" marL="0">
+            <a:pPr marL="0" indent="0">
               <a:buNone/>
             </a:pPr>
             <a:r>
@@ -13220,7 +13469,7 @@
             <a:endParaRPr lang="en-US" sz="1200" dirty="0"/>
           </a:p>
           <a:p>
-            <a:pPr indent="0" marL="0">
+            <a:pPr marL="0" indent="0">
               <a:buNone/>
             </a:pPr>
             <a:r>
@@ -13237,7 +13486,7 @@
             <a:endParaRPr lang="en-US" sz="1200" dirty="0"/>
           </a:p>
           <a:p>
-            <a:pPr indent="0" marL="0">
+            <a:pPr marL="0" indent="0">
               <a:buNone/>
             </a:pPr>
             <a:r>
@@ -13254,7 +13503,7 @@
             <a:endParaRPr lang="en-US" sz="1200" dirty="0"/>
           </a:p>
           <a:p>
-            <a:pPr indent="0" marL="0">
+            <a:pPr marL="0" indent="0">
               <a:buNone/>
             </a:pPr>
             <a:r>
@@ -13271,7 +13520,7 @@
             <a:endParaRPr lang="en-US" sz="1200" dirty="0"/>
           </a:p>
           <a:p>
-            <a:pPr indent="0" marL="0">
+            <a:pPr marL="0" indent="0">
               <a:buNone/>
             </a:pPr>
             <a:r>
@@ -13288,7 +13537,7 @@
             <a:endParaRPr lang="en-US" sz="1200" dirty="0"/>
           </a:p>
           <a:p>
-            <a:pPr indent="0" marL="0">
+            <a:pPr marL="0" indent="0">
               <a:buNone/>
             </a:pPr>
             <a:r>
@@ -13305,7 +13554,7 @@
             <a:endParaRPr lang="en-US" sz="1200" dirty="0"/>
           </a:p>
           <a:p>
-            <a:pPr indent="0" marL="0">
+            <a:pPr marL="0" indent="0">
               <a:buNone/>
             </a:pPr>
             <a:r>
@@ -13343,7 +13592,7 @@
           </a:prstGeom>
           <a:extLst>
             <a:ext uri="{C572A759-6A51-4108-AA02-DFA0A04FC94B}">
-              <ma14:wrappingTextBoxFlag xmlns:ma14="http://schemas.microsoft.com/office/mac/drawingml/2011/main" val="0"/>
+              <ma14:wrappingTextBoxFlag xmlns:ma14="http://schemas.microsoft.com/office/mac/drawingml/2011/main" xmlns="" val="0"/>
             </a:ext>
           </a:extLst>
         </p:spPr>
@@ -13361,7 +13610,7 @@
           <a:p>
             <a:pPr algn="r"/>
             <a:fld id="{F7021451-1387-4CA6-816F-3879F97B5CBC}" type="slidenum">
-              <a:rPr b="0" lang="en-US"/>
+              <a:rPr lang="en-US" b="0"/>
               <a:t>9</a:t>
             </a:fld>
             <a:endParaRPr lang="en-US"/>
@@ -13669,4 +13918,319 @@
     </a:ext>
   </a:extLst>
 </a:theme>
+</file>
+
+<file path=ppt/theme/theme2.xml><?xml version="1.0" encoding="utf-8"?>
+<a:theme xmlns:a="http://schemas.openxmlformats.org/drawingml/2006/main" name="Office Theme">
+  <a:themeElements>
+    <a:clrScheme name="Office">
+      <a:dk1>
+        <a:sysClr val="windowText" lastClr="000000"/>
+      </a:dk1>
+      <a:lt1>
+        <a:sysClr val="window" lastClr="FFFFFF"/>
+      </a:lt1>
+      <a:dk2>
+        <a:srgbClr val="0E2841"/>
+      </a:dk2>
+      <a:lt2>
+        <a:srgbClr val="E8E8E8"/>
+      </a:lt2>
+      <a:accent1>
+        <a:srgbClr val="156082"/>
+      </a:accent1>
+      <a:accent2>
+        <a:srgbClr val="E97132"/>
+      </a:accent2>
+      <a:accent3>
+        <a:srgbClr val="196B24"/>
+      </a:accent3>
+      <a:accent4>
+        <a:srgbClr val="0F9ED5"/>
+      </a:accent4>
+      <a:accent5>
+        <a:srgbClr val="A02B93"/>
+      </a:accent5>
+      <a:accent6>
+        <a:srgbClr val="4EA72E"/>
+      </a:accent6>
+      <a:hlink>
+        <a:srgbClr val="467886"/>
+      </a:hlink>
+      <a:folHlink>
+        <a:srgbClr val="96607D"/>
+      </a:folHlink>
+    </a:clrScheme>
+    <a:fontScheme name="Office">
+      <a:majorFont>
+        <a:latin typeface="Aptos Display" panose="02110004020202020204"/>
+        <a:ea typeface=""/>
+        <a:cs typeface=""/>
+        <a:font script="Jpan" typeface="游ゴシック Light"/>
+        <a:font script="Hang" typeface="맑은 고딕"/>
+        <a:font script="Hans" typeface="等线 Light"/>
+        <a:font script="Hant" typeface="新細明體"/>
+        <a:font script="Arab" typeface="Times New Roman"/>
+        <a:font script="Hebr" typeface="Times New Roman"/>
+        <a:font script="Thai" typeface="Angsana New"/>
+        <a:font script="Ethi" typeface="Nyala"/>
+        <a:font script="Beng" typeface="Vrinda"/>
+        <a:font script="Gujr" typeface="Shruti"/>
+        <a:font script="Khmr" typeface="MoolBoran"/>
+        <a:font script="Knda" typeface="Tunga"/>
+        <a:font script="Guru" typeface="Raavi"/>
+        <a:font script="Cans" typeface="Euphemia"/>
+        <a:font script="Cher" typeface="Plantagenet Cherokee"/>
+        <a:font script="Yiii" typeface="Microsoft Yi Baiti"/>
+        <a:font script="Tibt" typeface="Microsoft Himalaya"/>
+        <a:font script="Thaa" typeface="MV Boli"/>
+        <a:font script="Deva" typeface="Mangal"/>
+        <a:font script="Telu" typeface="Gautami"/>
+        <a:font script="Taml" typeface="Latha"/>
+        <a:font script="Syrc" typeface="Estrangelo Edessa"/>
+        <a:font script="Orya" typeface="Kalinga"/>
+        <a:font script="Mlym" typeface="Kartika"/>
+        <a:font script="Laoo" typeface="DokChampa"/>
+        <a:font script="Sinh" typeface="Iskoola Pota"/>
+        <a:font script="Mong" typeface="Mongolian Baiti"/>
+        <a:font script="Viet" typeface="Times New Roman"/>
+        <a:font script="Uigh" typeface="Microsoft Uighur"/>
+        <a:font script="Geor" typeface="Sylfaen"/>
+        <a:font script="Armn" typeface="Arial"/>
+        <a:font script="Bugi" typeface="Leelawadee UI"/>
+        <a:font script="Bopo" typeface="Microsoft JhengHei"/>
+        <a:font script="Java" typeface="Javanese Text"/>
+        <a:font script="Lisu" typeface="Segoe UI"/>
+        <a:font script="Mymr" typeface="Myanmar Text"/>
+        <a:font script="Nkoo" typeface="Ebrima"/>
+        <a:font script="Olck" typeface="Nirmala UI"/>
+        <a:font script="Osma" typeface="Ebrima"/>
+        <a:font script="Phag" typeface="Phagspa"/>
+        <a:font script="Syrn" typeface="Estrangelo Edessa"/>
+        <a:font script="Syrj" typeface="Estrangelo Edessa"/>
+        <a:font script="Syre" typeface="Estrangelo Edessa"/>
+        <a:font script="Sora" typeface="Nirmala UI"/>
+        <a:font script="Tale" typeface="Microsoft Tai Le"/>
+        <a:font script="Talu" typeface="Microsoft New Tai Lue"/>
+        <a:font script="Tfng" typeface="Ebrima"/>
+      </a:majorFont>
+      <a:minorFont>
+        <a:latin typeface="Aptos" panose="02110004020202020204"/>
+        <a:ea typeface=""/>
+        <a:cs typeface=""/>
+        <a:font script="Jpan" typeface="游ゴシック"/>
+        <a:font script="Hang" typeface="맑은 고딕"/>
+        <a:font script="Hans" typeface="等线"/>
+        <a:font script="Hant" typeface="新細明體"/>
+        <a:font script="Arab" typeface="Arial"/>
+        <a:font script="Hebr" typeface="Arial"/>
+        <a:font script="Thai" typeface="Cordia New"/>
+        <a:font script="Ethi" typeface="Nyala"/>
+        <a:font script="Beng" typeface="Vrinda"/>
+        <a:font script="Gujr" typeface="Shruti"/>
+        <a:font script="Khmr" typeface="DaunPenh"/>
+        <a:font script="Knda" typeface="Tunga"/>
+        <a:font script="Guru" typeface="Raavi"/>
+        <a:font script="Cans" typeface="Euphemia"/>
+        <a:font script="Cher" typeface="Plantagenet Cherokee"/>
+        <a:font script="Yiii" typeface="Microsoft Yi Baiti"/>
+        <a:font script="Tibt" typeface="Microsoft Himalaya"/>
+        <a:font script="Thaa" typeface="MV Boli"/>
+        <a:font script="Deva" typeface="Mangal"/>
+        <a:font script="Telu" typeface="Gautami"/>
+        <a:font script="Taml" typeface="Latha"/>
+        <a:font script="Syrc" typeface="Estrangelo Edessa"/>
+        <a:font script="Orya" typeface="Kalinga"/>
+        <a:font script="Mlym" typeface="Kartika"/>
+        <a:font script="Laoo" typeface="DokChampa"/>
+        <a:font script="Sinh" typeface="Iskoola Pota"/>
+        <a:font script="Mong" typeface="Mongolian Baiti"/>
+        <a:font script="Viet" typeface="Arial"/>
+        <a:font script="Uigh" typeface="Microsoft Uighur"/>
+        <a:font script="Geor" typeface="Sylfaen"/>
+        <a:font script="Armn" typeface="Arial"/>
+        <a:font script="Bugi" typeface="Leelawadee UI"/>
+        <a:font script="Bopo" typeface="Microsoft JhengHei"/>
+        <a:font script="Java" typeface="Javanese Text"/>
+        <a:font script="Lisu" typeface="Segoe UI"/>
+        <a:font script="Mymr" typeface="Myanmar Text"/>
+        <a:font script="Nkoo" typeface="Ebrima"/>
+        <a:font script="Olck" typeface="Nirmala UI"/>
+        <a:font script="Osma" typeface="Ebrima"/>
+        <a:font script="Phag" typeface="Phagspa"/>
+        <a:font script="Syrn" typeface="Estrangelo Edessa"/>
+        <a:font script="Syrj" typeface="Estrangelo Edessa"/>
+        <a:font script="Syre" typeface="Estrangelo Edessa"/>
+        <a:font script="Sora" typeface="Nirmala UI"/>
+        <a:font script="Tale" typeface="Microsoft Tai Le"/>
+        <a:font script="Talu" typeface="Microsoft New Tai Lue"/>
+        <a:font script="Tfng" typeface="Ebrima"/>
+      </a:minorFont>
+    </a:fontScheme>
+    <a:fmtScheme name="Office">
+      <a:fillStyleLst>
+        <a:solidFill>
+          <a:schemeClr val="phClr"/>
+        </a:solidFill>
+        <a:gradFill rotWithShape="1">
+          <a:gsLst>
+            <a:gs pos="0">
+              <a:schemeClr val="phClr">
+                <a:lumMod val="110000"/>
+                <a:satMod val="105000"/>
+                <a:tint val="67000"/>
+              </a:schemeClr>
+            </a:gs>
+            <a:gs pos="50000">
+              <a:schemeClr val="phClr">
+                <a:lumMod val="105000"/>
+                <a:satMod val="103000"/>
+                <a:tint val="73000"/>
+              </a:schemeClr>
+            </a:gs>
+            <a:gs pos="100000">
+              <a:schemeClr val="phClr">
+                <a:lumMod val="105000"/>
+                <a:satMod val="109000"/>
+                <a:tint val="81000"/>
+              </a:schemeClr>
+            </a:gs>
+          </a:gsLst>
+          <a:lin ang="5400000" scaled="0"/>
+        </a:gradFill>
+        <a:gradFill rotWithShape="1">
+          <a:gsLst>
+            <a:gs pos="0">
+              <a:schemeClr val="phClr">
+                <a:satMod val="103000"/>
+                <a:lumMod val="102000"/>
+                <a:tint val="94000"/>
+              </a:schemeClr>
+            </a:gs>
+            <a:gs pos="50000">
+              <a:schemeClr val="phClr">
+                <a:satMod val="110000"/>
+                <a:lumMod val="100000"/>
+                <a:shade val="100000"/>
+              </a:schemeClr>
+            </a:gs>
+            <a:gs pos="100000">
+              <a:schemeClr val="phClr">
+                <a:lumMod val="99000"/>
+                <a:satMod val="120000"/>
+                <a:shade val="78000"/>
+              </a:schemeClr>
+            </a:gs>
+          </a:gsLst>
+          <a:lin ang="5400000" scaled="0"/>
+        </a:gradFill>
+      </a:fillStyleLst>
+      <a:lnStyleLst>
+        <a:ln w="12700" cap="flat" cmpd="sng" algn="ctr">
+          <a:solidFill>
+            <a:schemeClr val="phClr"/>
+          </a:solidFill>
+          <a:prstDash val="solid"/>
+          <a:miter lim="800000"/>
+        </a:ln>
+        <a:ln w="19050" cap="flat" cmpd="sng" algn="ctr">
+          <a:solidFill>
+            <a:schemeClr val="phClr"/>
+          </a:solidFill>
+          <a:prstDash val="solid"/>
+          <a:miter lim="800000"/>
+        </a:ln>
+        <a:ln w="25400" cap="flat" cmpd="sng" algn="ctr">
+          <a:solidFill>
+            <a:schemeClr val="phClr"/>
+          </a:solidFill>
+          <a:prstDash val="solid"/>
+          <a:miter lim="800000"/>
+        </a:ln>
+      </a:lnStyleLst>
+      <a:effectStyleLst>
+        <a:effectStyle>
+          <a:effectLst/>
+        </a:effectStyle>
+        <a:effectStyle>
+          <a:effectLst/>
+        </a:effectStyle>
+        <a:effectStyle>
+          <a:effectLst>
+            <a:outerShdw blurRad="57150" dist="19050" dir="5400000" algn="ctr" rotWithShape="0">
+              <a:srgbClr val="000000">
+                <a:alpha val="63000"/>
+              </a:srgbClr>
+            </a:outerShdw>
+          </a:effectLst>
+        </a:effectStyle>
+      </a:effectStyleLst>
+      <a:bgFillStyleLst>
+        <a:solidFill>
+          <a:schemeClr val="phClr"/>
+        </a:solidFill>
+        <a:solidFill>
+          <a:schemeClr val="phClr">
+            <a:tint val="95000"/>
+            <a:satMod val="170000"/>
+          </a:schemeClr>
+        </a:solidFill>
+        <a:gradFill rotWithShape="1">
+          <a:gsLst>
+            <a:gs pos="0">
+              <a:schemeClr val="phClr">
+                <a:tint val="93000"/>
+                <a:satMod val="150000"/>
+                <a:shade val="98000"/>
+                <a:lumMod val="102000"/>
+              </a:schemeClr>
+            </a:gs>
+            <a:gs pos="50000">
+              <a:schemeClr val="phClr">
+                <a:tint val="98000"/>
+                <a:satMod val="130000"/>
+                <a:shade val="90000"/>
+                <a:lumMod val="103000"/>
+              </a:schemeClr>
+            </a:gs>
+            <a:gs pos="100000">
+              <a:schemeClr val="phClr">
+                <a:shade val="63000"/>
+                <a:satMod val="120000"/>
+              </a:schemeClr>
+            </a:gs>
+          </a:gsLst>
+          <a:lin ang="5400000" scaled="0"/>
+        </a:gradFill>
+      </a:bgFillStyleLst>
+    </a:fmtScheme>
+  </a:themeElements>
+  <a:objectDefaults>
+    <a:lnDef>
+      <a:spPr/>
+      <a:bodyPr/>
+      <a:lstStyle/>
+      <a:style>
+        <a:lnRef idx="2">
+          <a:schemeClr val="accent1"/>
+        </a:lnRef>
+        <a:fillRef idx="0">
+          <a:schemeClr val="accent1"/>
+        </a:fillRef>
+        <a:effectRef idx="1">
+          <a:schemeClr val="accent1"/>
+        </a:effectRef>
+        <a:fontRef idx="minor">
+          <a:schemeClr val="tx1"/>
+        </a:fontRef>
+      </a:style>
+    </a:lnDef>
+  </a:objectDefaults>
+  <a:extraClrSchemeLst/>
+  <a:extLst>
+    <a:ext uri="{05A4C25C-085E-4340-85A3-A5531E510DB2}">
+      <thm15:themeFamily xmlns:thm15="http://schemas.microsoft.com/office/thememl/2012/main" name="Office Theme" id="{2E142A2C-CD16-42D6-873A-C26D2A0506FA}" vid="{1BDDFF52-6CD6-40A5-AB3C-68EB2F1E4D0A}"/>
+    </a:ext>
+  </a:extLst>
+</a:theme>
 </file>
</xml_diff>